<commit_message>
RAC 1·6·8·9·12~20장 pptx, v2 설치 가이드, SECURITY 19c 원본 갱신
Co-Authored-By: Claude Opus 5.5 <noreply@anthropic.com>
</commit_message>
<xml_diff>
--- a/RAC/06장/6장_ASM인스턴스와디스크그룹.pptx
+++ b/RAC/06장/6장_ASM인스턴스와디스크그룹.pptx
@@ -4,46 +4,49 @@
   <p:sldMasterIdLst>
     <p:sldMasterId id="2147483648" r:id="rId1"/>
   </p:sldMasterIdLst>
+  <p:notesMasterIdLst>
+    <p:notesMasterId r:id="rId39"/>
+  </p:notesMasterIdLst>
   <p:sldIdLst>
-    <p:sldId id="256" r:id="rId7"/>
-    <p:sldId id="257" r:id="rId8"/>
-    <p:sldId id="258" r:id="rId9"/>
-    <p:sldId id="259" r:id="rId10"/>
-    <p:sldId id="260" r:id="rId11"/>
-    <p:sldId id="261" r:id="rId13"/>
-    <p:sldId id="262" r:id="rId14"/>
-    <p:sldId id="263" r:id="rId15"/>
-    <p:sldId id="264" r:id="rId16"/>
-    <p:sldId id="265" r:id="rId17"/>
-    <p:sldId id="266" r:id="rId18"/>
-    <p:sldId id="267" r:id="rId19"/>
-    <p:sldId id="268" r:id="rId20"/>
-    <p:sldId id="269" r:id="rId21"/>
-    <p:sldId id="270" r:id="rId22"/>
-    <p:sldId id="271" r:id="rId23"/>
-    <p:sldId id="272" r:id="rId24"/>
-    <p:sldId id="273" r:id="rId25"/>
-    <p:sldId id="274" r:id="rId26"/>
-    <p:sldId id="275" r:id="rId27"/>
-    <p:sldId id="276" r:id="rId28"/>
-    <p:sldId id="277" r:id="rId29"/>
-    <p:sldId id="278" r:id="rId30"/>
-    <p:sldId id="279" r:id="rId31"/>
-    <p:sldId id="280" r:id="rId32"/>
-    <p:sldId id="281" r:id="rId33"/>
-    <p:sldId id="282" r:id="rId34"/>
-    <p:sldId id="283" r:id="rId35"/>
-    <p:sldId id="284" r:id="rId36"/>
-    <p:sldId id="285" r:id="rId37"/>
-    <p:sldId id="286" r:id="rId38"/>
-    <p:sldId id="287" r:id="rId39"/>
-    <p:sldId id="288" r:id="rId40"/>
-    <p:sldId id="289" r:id="rId41"/>
-    <p:sldId id="290" r:id="rId42"/>
-    <p:sldId id="291" r:id="rId43"/>
-    <p:sldId id="292" r:id="rId44"/>
+    <p:sldId id="256" r:id="rId2"/>
+    <p:sldId id="257" r:id="rId3"/>
+    <p:sldId id="258" r:id="rId4"/>
+    <p:sldId id="259" r:id="rId5"/>
+    <p:sldId id="260" r:id="rId6"/>
+    <p:sldId id="261" r:id="rId7"/>
+    <p:sldId id="262" r:id="rId8"/>
+    <p:sldId id="263" r:id="rId9"/>
+    <p:sldId id="264" r:id="rId10"/>
+    <p:sldId id="265" r:id="rId11"/>
+    <p:sldId id="266" r:id="rId12"/>
+    <p:sldId id="267" r:id="rId13"/>
+    <p:sldId id="268" r:id="rId14"/>
+    <p:sldId id="269" r:id="rId15"/>
+    <p:sldId id="270" r:id="rId16"/>
+    <p:sldId id="271" r:id="rId17"/>
+    <p:sldId id="272" r:id="rId18"/>
+    <p:sldId id="273" r:id="rId19"/>
+    <p:sldId id="274" r:id="rId20"/>
+    <p:sldId id="275" r:id="rId21"/>
+    <p:sldId id="276" r:id="rId22"/>
+    <p:sldId id="277" r:id="rId23"/>
+    <p:sldId id="278" r:id="rId24"/>
+    <p:sldId id="279" r:id="rId25"/>
+    <p:sldId id="280" r:id="rId26"/>
+    <p:sldId id="281" r:id="rId27"/>
+    <p:sldId id="282" r:id="rId28"/>
+    <p:sldId id="283" r:id="rId29"/>
+    <p:sldId id="284" r:id="rId30"/>
+    <p:sldId id="285" r:id="rId31"/>
+    <p:sldId id="286" r:id="rId32"/>
+    <p:sldId id="287" r:id="rId33"/>
+    <p:sldId id="288" r:id="rId34"/>
+    <p:sldId id="289" r:id="rId35"/>
+    <p:sldId id="290" r:id="rId36"/>
+    <p:sldId id="291" r:id="rId37"/>
+    <p:sldId id="292" r:id="rId38"/>
   </p:sldIdLst>
-  <p:sldSz cx="12191695" cy="6858000" type="screen4x3"/>
+  <p:sldSz cx="12192000" cy="6858000"/>
   <p:notesSz cx="6858000" cy="9144000"/>
   <p:defaultTextStyle>
     <a:defPPr>
@@ -140,11 +143,27 @@
       </a:defRPr>
     </a:lvl9pPr>
   </p:defaultTextStyle>
+  <p:extLst>
+    <p:ext uri="{EFAFB233-063F-42B5-8137-9DF3F51BA10A}">
+      <p15:sldGuideLst xmlns:p15="http://schemas.microsoft.com/office/powerpoint/2012/main">
+        <p15:guide id="1" orient="horz" pos="2160">
+          <p15:clr>
+            <a:srgbClr val="A4A3A4"/>
+          </p15:clr>
+        </p15:guide>
+        <p15:guide id="2" pos="2880">
+          <p15:clr>
+            <a:srgbClr val="A4A3A4"/>
+          </p15:clr>
+        </p15:guide>
+      </p15:sldGuideLst>
+    </p:ext>
+  </p:extLst>
 </p:presentation>
 </file>
 
 <file path=ppt/notesMasters/notesMaster1.xml><?xml version="1.0" encoding="utf-8"?>
-<p:notesMaster xmlns:a="http://schemas.openxmlformats.org/drawingml/2006/main" xmlns:p="http://schemas.openxmlformats.org/presentationml/2006/main" xmlns:r="http://schemas.openxmlformats.org/officeDocument/2006/relationships">
+<p:notesMaster xmlns:a="http://schemas.openxmlformats.org/drawingml/2006/main" xmlns:r="http://schemas.openxmlformats.org/officeDocument/2006/relationships" xmlns:p="http://schemas.openxmlformats.org/presentationml/2006/main">
   <p:cSld>
     <p:bg>
       <p:bgRef idx="1001">
@@ -167,7 +186,7 @@
       </p:grpSpPr>
       <p:sp>
         <p:nvSpPr>
-          <p:cNvPr id="2" name="Header Placeholder 1"/>
+          <p:cNvPr id="2" name="머리글 개체 틀 1"/>
           <p:cNvSpPr>
             <a:spLocks noGrp="1"/>
           </p:cNvSpPr>
@@ -178,7 +197,7 @@
         <p:spPr>
           <a:xfrm>
             <a:off x="0" y="0"/>
-            <a:ext cx="2971800" cy="457200"/>
+            <a:ext cx="2971800" cy="458788"/>
           </a:xfrm>
           <a:prstGeom prst="rect">
             <a:avLst/>
@@ -192,13 +211,13 @@
             </a:lvl1pPr>
           </a:lstStyle>
           <a:p>
-            <a:endParaRPr lang="en-US"/>
-          </a:p>
-        </p:txBody>
-      </p:sp>
-      <p:sp>
-        <p:nvSpPr>
-          <p:cNvPr id="3" name="Date Placeholder 2"/>
+            <a:endParaRPr lang="ko-KR" altLang="en-US"/>
+          </a:p>
+        </p:txBody>
+      </p:sp>
+      <p:sp>
+        <p:nvSpPr>
+          <p:cNvPr id="3" name="날짜 개체 틀 2"/>
           <p:cNvSpPr>
             <a:spLocks noGrp="1"/>
           </p:cNvSpPr>
@@ -209,7 +228,7 @@
         <p:spPr>
           <a:xfrm>
             <a:off x="3884613" y="0"/>
-            <a:ext cx="2971800" cy="457200"/>
+            <a:ext cx="2971800" cy="458788"/>
           </a:xfrm>
           <a:prstGeom prst="rect">
             <a:avLst/>
@@ -223,17 +242,17 @@
             </a:lvl1pPr>
           </a:lstStyle>
           <a:p>
-            <a:fld id="{0F89C1C7-3DCD-1040-A9CF-14679D8B5DDD}" type="datetimeFigureOut">
-              <a:rPr lang="en-US" smtClean="0"/>
-              <a:t>10/17/16</a:t>
+            <a:fld id="{C73C15F9-7829-416F-A5D8-8D802FC6DAE1}" type="datetimeFigureOut">
+              <a:rPr lang="ko-KR" altLang="en-US" smtClean="0"/>
+              <a:t>2026-10-29</a:t>
             </a:fld>
-            <a:endParaRPr lang="en-US"/>
-          </a:p>
-        </p:txBody>
-      </p:sp>
-      <p:sp>
-        <p:nvSpPr>
-          <p:cNvPr id="4" name="Slide Image Placeholder 3"/>
+            <a:endParaRPr lang="ko-KR" altLang="en-US"/>
+          </a:p>
+        </p:txBody>
+      </p:sp>
+      <p:sp>
+        <p:nvSpPr>
+          <p:cNvPr id="4" name="슬라이드 이미지 개체 틀 3"/>
           <p:cNvSpPr>
             <a:spLocks noGrp="1" noRot="1" noChangeAspect="1"/>
           </p:cNvSpPr>
@@ -243,8 +262,8 @@
         </p:nvSpPr>
         <p:spPr>
           <a:xfrm>
-            <a:off x="1143000" y="685800"/>
-            <a:ext cx="4572000" cy="3429000"/>
+            <a:off x="685800" y="1143000"/>
+            <a:ext cx="5486400" cy="3086100"/>
           </a:xfrm>
           <a:prstGeom prst="rect">
             <a:avLst/>
@@ -260,13 +279,13 @@
           <a:bodyPr vert="horz" lIns="91440" tIns="45720" rIns="91440" bIns="45720" rtlCol="0" anchor="ctr"/>
           <a:lstStyle/>
           <a:p>
-            <a:endParaRPr lang="en-US"/>
-          </a:p>
-        </p:txBody>
-      </p:sp>
-      <p:sp>
-        <p:nvSpPr>
-          <p:cNvPr id="5" name="Notes Placeholder 4"/>
+            <a:endParaRPr lang="ko-KR" altLang="en-US"/>
+          </a:p>
+        </p:txBody>
+      </p:sp>
+      <p:sp>
+        <p:nvSpPr>
+          <p:cNvPr id="5" name="슬라이드 노트 개체 틀 4"/>
           <p:cNvSpPr>
             <a:spLocks noGrp="1"/>
           </p:cNvSpPr>
@@ -276,8 +295,8 @@
         </p:nvSpPr>
         <p:spPr>
           <a:xfrm>
-            <a:off x="685800" y="4343400"/>
-            <a:ext cx="5486400" cy="4114800"/>
+            <a:off x="685800" y="4400550"/>
+            <a:ext cx="5486400" cy="3600450"/>
           </a:xfrm>
           <a:prstGeom prst="rect">
             <a:avLst/>
@@ -289,44 +308,43 @@
           <a:p>
             <a:pPr lvl="0"/>
             <a:r>
-              <a:rPr lang="en-US" smtClean="0"/>
-              <a:t>Click to edit Master text styles</a:t>
+              <a:rPr lang="ko-KR" altLang="en-US"/>
+              <a:t>마스터 텍스트 스타일을 편집하려면 클릭</a:t>
             </a:r>
           </a:p>
           <a:p>
             <a:pPr lvl="1"/>
             <a:r>
-              <a:rPr lang="en-US" smtClean="0"/>
-              <a:t>Second level</a:t>
+              <a:rPr lang="ko-KR" altLang="en-US"/>
+              <a:t>두 번째 수준</a:t>
             </a:r>
           </a:p>
           <a:p>
             <a:pPr lvl="2"/>
             <a:r>
-              <a:rPr lang="en-US" smtClean="0"/>
-              <a:t>Third level</a:t>
+              <a:rPr lang="ko-KR" altLang="en-US"/>
+              <a:t>세 번째 수준</a:t>
             </a:r>
           </a:p>
           <a:p>
             <a:pPr lvl="3"/>
             <a:r>
-              <a:rPr lang="en-US" smtClean="0"/>
-              <a:t>Fourth level</a:t>
+              <a:rPr lang="ko-KR" altLang="en-US"/>
+              <a:t>네 번째 수준</a:t>
             </a:r>
           </a:p>
           <a:p>
             <a:pPr lvl="4"/>
             <a:r>
-              <a:rPr lang="en-US" smtClean="0"/>
-              <a:t>Fifth level</a:t>
-            </a:r>
-            <a:endParaRPr lang="en-US"/>
-          </a:p>
-        </p:txBody>
-      </p:sp>
-      <p:sp>
-        <p:nvSpPr>
-          <p:cNvPr id="6" name="Footer Placeholder 5"/>
+              <a:rPr lang="ko-KR" altLang="en-US"/>
+              <a:t>다섯 번째 수준</a:t>
+            </a:r>
+          </a:p>
+        </p:txBody>
+      </p:sp>
+      <p:sp>
+        <p:nvSpPr>
+          <p:cNvPr id="6" name="바닥글 개체 틀 5"/>
           <p:cNvSpPr>
             <a:spLocks noGrp="1"/>
           </p:cNvSpPr>
@@ -337,7 +355,7 @@
         <p:spPr>
           <a:xfrm>
             <a:off x="0" y="8685213"/>
-            <a:ext cx="2971800" cy="457200"/>
+            <a:ext cx="2971800" cy="458787"/>
           </a:xfrm>
           <a:prstGeom prst="rect">
             <a:avLst/>
@@ -351,13 +369,13 @@
             </a:lvl1pPr>
           </a:lstStyle>
           <a:p>
-            <a:endParaRPr lang="en-US"/>
-          </a:p>
-        </p:txBody>
-      </p:sp>
-      <p:sp>
-        <p:nvSpPr>
-          <p:cNvPr id="7" name="Slide Number Placeholder 6"/>
+            <a:endParaRPr lang="ko-KR" altLang="en-US"/>
+          </a:p>
+        </p:txBody>
+      </p:sp>
+      <p:sp>
+        <p:nvSpPr>
+          <p:cNvPr id="7" name="슬라이드 번호 개체 틀 6"/>
           <p:cNvSpPr>
             <a:spLocks noGrp="1"/>
           </p:cNvSpPr>
@@ -368,7 +386,7 @@
         <p:spPr>
           <a:xfrm>
             <a:off x="3884613" y="8685213"/>
-            <a:ext cx="2971800" cy="457200"/>
+            <a:ext cx="2971800" cy="458787"/>
           </a:xfrm>
           <a:prstGeom prst="rect">
             <a:avLst/>
@@ -382,24 +400,24 @@
             </a:lvl1pPr>
           </a:lstStyle>
           <a:p>
-            <a:fld id="{BB5E49A5-4136-284D-997B-48E1D791AD67}" type="slidenum">
-              <a:rPr lang="en-US" smtClean="0"/>
+            <a:fld id="{D55C410E-31FE-4870-8126-6BDBF221F847}" type="slidenum">
+              <a:rPr lang="ko-KR" altLang="en-US" smtClean="0"/>
               <a:t>‹#›</a:t>
             </a:fld>
-            <a:endParaRPr lang="en-US"/>
+            <a:endParaRPr lang="ko-KR" altLang="en-US"/>
           </a:p>
         </p:txBody>
       </p:sp>
     </p:spTree>
     <p:extLst>
       <p:ext uri="{BB962C8B-B14F-4D97-AF65-F5344CB8AC3E}">
-        <p14:creationId xmlns:p14="http://schemas.microsoft.com/office/powerpoint/2010/main" val="2623252185"/>
+        <p14:creationId xmlns:p14="http://schemas.microsoft.com/office/powerpoint/2010/main" val="1648730541"/>
       </p:ext>
     </p:extLst>
   </p:cSld>
   <p:clrMap bg1="lt1" tx1="dk1" bg2="lt2" tx2="dk2" accent1="accent1" accent2="accent2" accent3="accent3" accent4="accent4" accent5="accent5" accent6="accent6" hlink="hlink" folHlink="folHlink"/>
   <p:notesStyle>
-    <a:lvl1pPr marL="0" algn="l" defTabSz="457200" rtl="0" eaLnBrk="1" latinLnBrk="0" hangingPunct="1">
+    <a:lvl1pPr marL="0" algn="l" defTabSz="914400" rtl="0" eaLnBrk="1" latinLnBrk="1" hangingPunct="1">
       <a:defRPr sz="1200" kern="1200">
         <a:solidFill>
           <a:schemeClr val="tx1"/>
@@ -409,7 +427,7 @@
         <a:cs typeface="+mn-cs"/>
       </a:defRPr>
     </a:lvl1pPr>
-    <a:lvl2pPr marL="457200" algn="l" defTabSz="457200" rtl="0" eaLnBrk="1" latinLnBrk="0" hangingPunct="1">
+    <a:lvl2pPr marL="457200" algn="l" defTabSz="914400" rtl="0" eaLnBrk="1" latinLnBrk="1" hangingPunct="1">
       <a:defRPr sz="1200" kern="1200">
         <a:solidFill>
           <a:schemeClr val="tx1"/>
@@ -419,7 +437,7 @@
         <a:cs typeface="+mn-cs"/>
       </a:defRPr>
     </a:lvl2pPr>
-    <a:lvl3pPr marL="914400" algn="l" defTabSz="457200" rtl="0" eaLnBrk="1" latinLnBrk="0" hangingPunct="1">
+    <a:lvl3pPr marL="914400" algn="l" defTabSz="914400" rtl="0" eaLnBrk="1" latinLnBrk="1" hangingPunct="1">
       <a:defRPr sz="1200" kern="1200">
         <a:solidFill>
           <a:schemeClr val="tx1"/>
@@ -429,7 +447,7 @@
         <a:cs typeface="+mn-cs"/>
       </a:defRPr>
     </a:lvl3pPr>
-    <a:lvl4pPr marL="1371600" algn="l" defTabSz="457200" rtl="0" eaLnBrk="1" latinLnBrk="0" hangingPunct="1">
+    <a:lvl4pPr marL="1371600" algn="l" defTabSz="914400" rtl="0" eaLnBrk="1" latinLnBrk="1" hangingPunct="1">
       <a:defRPr sz="1200" kern="1200">
         <a:solidFill>
           <a:schemeClr val="tx1"/>
@@ -439,7 +457,7 @@
         <a:cs typeface="+mn-cs"/>
       </a:defRPr>
     </a:lvl4pPr>
-    <a:lvl5pPr marL="1828800" algn="l" defTabSz="457200" rtl="0" eaLnBrk="1" latinLnBrk="0" hangingPunct="1">
+    <a:lvl5pPr marL="1828800" algn="l" defTabSz="914400" rtl="0" eaLnBrk="1" latinLnBrk="1" hangingPunct="1">
       <a:defRPr sz="1200" kern="1200">
         <a:solidFill>
           <a:schemeClr val="tx1"/>
@@ -449,7 +467,7 @@
         <a:cs typeface="+mn-cs"/>
       </a:defRPr>
     </a:lvl5pPr>
-    <a:lvl6pPr marL="2286000" algn="l" defTabSz="457200" rtl="0" eaLnBrk="1" latinLnBrk="0" hangingPunct="1">
+    <a:lvl6pPr marL="2286000" algn="l" defTabSz="914400" rtl="0" eaLnBrk="1" latinLnBrk="1" hangingPunct="1">
       <a:defRPr sz="1200" kern="1200">
         <a:solidFill>
           <a:schemeClr val="tx1"/>
@@ -459,7 +477,7 @@
         <a:cs typeface="+mn-cs"/>
       </a:defRPr>
     </a:lvl6pPr>
-    <a:lvl7pPr marL="2743200" algn="l" defTabSz="457200" rtl="0" eaLnBrk="1" latinLnBrk="0" hangingPunct="1">
+    <a:lvl7pPr marL="2743200" algn="l" defTabSz="914400" rtl="0" eaLnBrk="1" latinLnBrk="1" hangingPunct="1">
       <a:defRPr sz="1200" kern="1200">
         <a:solidFill>
           <a:schemeClr val="tx1"/>
@@ -469,7 +487,7 @@
         <a:cs typeface="+mn-cs"/>
       </a:defRPr>
     </a:lvl7pPr>
-    <a:lvl8pPr marL="3200400" algn="l" defTabSz="457200" rtl="0" eaLnBrk="1" latinLnBrk="0" hangingPunct="1">
+    <a:lvl8pPr marL="3200400" algn="l" defTabSz="914400" rtl="0" eaLnBrk="1" latinLnBrk="1" hangingPunct="1">
       <a:defRPr sz="1200" kern="1200">
         <a:solidFill>
           <a:schemeClr val="tx1"/>
@@ -479,7 +497,7 @@
         <a:cs typeface="+mn-cs"/>
       </a:defRPr>
     </a:lvl8pPr>
-    <a:lvl9pPr marL="3657600" algn="l" defTabSz="457200" rtl="0" eaLnBrk="1" latinLnBrk="0" hangingPunct="1">
+    <a:lvl9pPr marL="3657600" algn="l" defTabSz="914400" rtl="0" eaLnBrk="1" latinLnBrk="1" hangingPunct="1">
       <a:defRPr sz="1200" kern="1200">
         <a:solidFill>
           <a:schemeClr val="tx1"/>
@@ -494,7 +512,7 @@
 </file>
 
 <file path=ppt/notesSlides/notesSlide1.xml><?xml version="1.0" encoding="utf-8"?>
-<p:notes xmlns:a="http://schemas.openxmlformats.org/drawingml/2006/main" xmlns:p="http://schemas.openxmlformats.org/presentationml/2006/main" xmlns:r="http://schemas.openxmlformats.org/officeDocument/2006/relationships">
+<p:notes xmlns:a="http://schemas.openxmlformats.org/drawingml/2006/main" xmlns:r="http://schemas.openxmlformats.org/officeDocument/2006/relationships" xmlns:p="http://schemas.openxmlformats.org/presentationml/2006/main">
   <p:cSld>
     <p:spTree>
       <p:nvGrpSpPr>
@@ -514,7 +532,7 @@
         <p:nvSpPr>
           <p:cNvPr id="2" name="Slide Image Placeholder 1"/>
           <p:cNvSpPr>
-            <a:spLocks noGrp="1"/>
+            <a:spLocks noGrp="1" noRot="1" noChangeAspect="1"/>
           </p:cNvSpPr>
           <p:nvPr>
             <p:ph type="sldImg" idx="2"/>
@@ -529,7 +547,7 @@
             <a:spLocks noGrp="1"/>
           </p:cNvSpPr>
           <p:nvPr>
-            <p:ph type="body" idx="3" sz="quarter"/>
+            <p:ph type="body" sz="quarter" idx="3"/>
           </p:nvPr>
         </p:nvSpPr>
         <p:spPr/>
@@ -550,7 +568,7 @@
             <a:spLocks noGrp="1"/>
           </p:cNvSpPr>
           <p:nvPr>
-            <p:ph type="sldNum" idx="5" sz="quarter"/>
+            <p:ph type="sldNum" sz="quarter" idx="5"/>
           </p:nvPr>
         </p:nvSpPr>
         <p:spPr/>
@@ -564,7 +582,7 @@
 </file>
 
 <file path=ppt/notesSlides/notesSlide10.xml><?xml version="1.0" encoding="utf-8"?>
-<p:notes xmlns:a="http://schemas.openxmlformats.org/drawingml/2006/main" xmlns:p="http://schemas.openxmlformats.org/presentationml/2006/main" xmlns:r="http://schemas.openxmlformats.org/officeDocument/2006/relationships">
+<p:notes xmlns:a="http://schemas.openxmlformats.org/drawingml/2006/main" xmlns:r="http://schemas.openxmlformats.org/officeDocument/2006/relationships" xmlns:p="http://schemas.openxmlformats.org/presentationml/2006/main">
   <p:cSld>
     <p:spTree>
       <p:nvGrpSpPr>
@@ -584,7 +602,7 @@
         <p:nvSpPr>
           <p:cNvPr id="2" name="Slide Image Placeholder 1"/>
           <p:cNvSpPr>
-            <a:spLocks noGrp="1"/>
+            <a:spLocks noGrp="1" noRot="1" noChangeAspect="1"/>
           </p:cNvSpPr>
           <p:nvPr>
             <p:ph type="sldImg" idx="2"/>
@@ -599,7 +617,7 @@
             <a:spLocks noGrp="1"/>
           </p:cNvSpPr>
           <p:nvPr>
-            <p:ph type="body" idx="3" sz="quarter"/>
+            <p:ph type="body" sz="quarter" idx="3"/>
           </p:nvPr>
         </p:nvSpPr>
         <p:spPr/>
@@ -620,7 +638,7 @@
             <a:spLocks noGrp="1"/>
           </p:cNvSpPr>
           <p:nvPr>
-            <p:ph type="sldNum" idx="5" sz="quarter"/>
+            <p:ph type="sldNum" sz="quarter" idx="5"/>
           </p:nvPr>
         </p:nvSpPr>
         <p:spPr/>
@@ -634,7 +652,7 @@
 </file>
 
 <file path=ppt/notesSlides/notesSlide11.xml><?xml version="1.0" encoding="utf-8"?>
-<p:notes xmlns:a="http://schemas.openxmlformats.org/drawingml/2006/main" xmlns:p="http://schemas.openxmlformats.org/presentationml/2006/main" xmlns:r="http://schemas.openxmlformats.org/officeDocument/2006/relationships">
+<p:notes xmlns:a="http://schemas.openxmlformats.org/drawingml/2006/main" xmlns:r="http://schemas.openxmlformats.org/officeDocument/2006/relationships" xmlns:p="http://schemas.openxmlformats.org/presentationml/2006/main">
   <p:cSld>
     <p:spTree>
       <p:nvGrpSpPr>
@@ -654,7 +672,7 @@
         <p:nvSpPr>
           <p:cNvPr id="2" name="Slide Image Placeholder 1"/>
           <p:cNvSpPr>
-            <a:spLocks noGrp="1"/>
+            <a:spLocks noGrp="1" noRot="1" noChangeAspect="1"/>
           </p:cNvSpPr>
           <p:nvPr>
             <p:ph type="sldImg" idx="2"/>
@@ -669,7 +687,7 @@
             <a:spLocks noGrp="1"/>
           </p:cNvSpPr>
           <p:nvPr>
-            <p:ph type="body" idx="3" sz="quarter"/>
+            <p:ph type="body" sz="quarter" idx="3"/>
           </p:nvPr>
         </p:nvSpPr>
         <p:spPr/>
@@ -690,7 +708,7 @@
             <a:spLocks noGrp="1"/>
           </p:cNvSpPr>
           <p:nvPr>
-            <p:ph type="sldNum" idx="5" sz="quarter"/>
+            <p:ph type="sldNum" sz="quarter" idx="5"/>
           </p:nvPr>
         </p:nvSpPr>
         <p:spPr/>
@@ -704,7 +722,7 @@
 </file>
 
 <file path=ppt/notesSlides/notesSlide12.xml><?xml version="1.0" encoding="utf-8"?>
-<p:notes xmlns:a="http://schemas.openxmlformats.org/drawingml/2006/main" xmlns:p="http://schemas.openxmlformats.org/presentationml/2006/main" xmlns:r="http://schemas.openxmlformats.org/officeDocument/2006/relationships">
+<p:notes xmlns:a="http://schemas.openxmlformats.org/drawingml/2006/main" xmlns:r="http://schemas.openxmlformats.org/officeDocument/2006/relationships" xmlns:p="http://schemas.openxmlformats.org/presentationml/2006/main">
   <p:cSld>
     <p:spTree>
       <p:nvGrpSpPr>
@@ -724,7 +742,7 @@
         <p:nvSpPr>
           <p:cNvPr id="2" name="Slide Image Placeholder 1"/>
           <p:cNvSpPr>
-            <a:spLocks noGrp="1"/>
+            <a:spLocks noGrp="1" noRot="1" noChangeAspect="1"/>
           </p:cNvSpPr>
           <p:nvPr>
             <p:ph type="sldImg" idx="2"/>
@@ -739,7 +757,7 @@
             <a:spLocks noGrp="1"/>
           </p:cNvSpPr>
           <p:nvPr>
-            <p:ph type="body" idx="3" sz="quarter"/>
+            <p:ph type="body" sz="quarter" idx="3"/>
           </p:nvPr>
         </p:nvSpPr>
         <p:spPr/>
@@ -760,7 +778,7 @@
             <a:spLocks noGrp="1"/>
           </p:cNvSpPr>
           <p:nvPr>
-            <p:ph type="sldNum" idx="5" sz="quarter"/>
+            <p:ph type="sldNum" sz="quarter" idx="5"/>
           </p:nvPr>
         </p:nvSpPr>
         <p:spPr/>
@@ -774,7 +792,7 @@
 </file>
 
 <file path=ppt/notesSlides/notesSlide13.xml><?xml version="1.0" encoding="utf-8"?>
-<p:notes xmlns:a="http://schemas.openxmlformats.org/drawingml/2006/main" xmlns:p="http://schemas.openxmlformats.org/presentationml/2006/main" xmlns:r="http://schemas.openxmlformats.org/officeDocument/2006/relationships">
+<p:notes xmlns:a="http://schemas.openxmlformats.org/drawingml/2006/main" xmlns:r="http://schemas.openxmlformats.org/officeDocument/2006/relationships" xmlns:p="http://schemas.openxmlformats.org/presentationml/2006/main">
   <p:cSld>
     <p:spTree>
       <p:nvGrpSpPr>
@@ -794,7 +812,7 @@
         <p:nvSpPr>
           <p:cNvPr id="2" name="Slide Image Placeholder 1"/>
           <p:cNvSpPr>
-            <a:spLocks noGrp="1"/>
+            <a:spLocks noGrp="1" noRot="1" noChangeAspect="1"/>
           </p:cNvSpPr>
           <p:nvPr>
             <p:ph type="sldImg" idx="2"/>
@@ -809,7 +827,7 @@
             <a:spLocks noGrp="1"/>
           </p:cNvSpPr>
           <p:nvPr>
-            <p:ph type="body" idx="3" sz="quarter"/>
+            <p:ph type="body" sz="quarter" idx="3"/>
           </p:nvPr>
         </p:nvSpPr>
         <p:spPr/>
@@ -830,7 +848,7 @@
             <a:spLocks noGrp="1"/>
           </p:cNvSpPr>
           <p:nvPr>
-            <p:ph type="sldNum" idx="5" sz="quarter"/>
+            <p:ph type="sldNum" sz="quarter" idx="5"/>
           </p:nvPr>
         </p:nvSpPr>
         <p:spPr/>
@@ -844,7 +862,7 @@
 </file>
 
 <file path=ppt/notesSlides/notesSlide14.xml><?xml version="1.0" encoding="utf-8"?>
-<p:notes xmlns:a="http://schemas.openxmlformats.org/drawingml/2006/main" xmlns:p="http://schemas.openxmlformats.org/presentationml/2006/main" xmlns:r="http://schemas.openxmlformats.org/officeDocument/2006/relationships">
+<p:notes xmlns:a="http://schemas.openxmlformats.org/drawingml/2006/main" xmlns:r="http://schemas.openxmlformats.org/officeDocument/2006/relationships" xmlns:p="http://schemas.openxmlformats.org/presentationml/2006/main">
   <p:cSld>
     <p:spTree>
       <p:nvGrpSpPr>
@@ -864,7 +882,7 @@
         <p:nvSpPr>
           <p:cNvPr id="2" name="Slide Image Placeholder 1"/>
           <p:cNvSpPr>
-            <a:spLocks noGrp="1"/>
+            <a:spLocks noGrp="1" noRot="1" noChangeAspect="1"/>
           </p:cNvSpPr>
           <p:nvPr>
             <p:ph type="sldImg" idx="2"/>
@@ -879,7 +897,7 @@
             <a:spLocks noGrp="1"/>
           </p:cNvSpPr>
           <p:nvPr>
-            <p:ph type="body" idx="3" sz="quarter"/>
+            <p:ph type="body" sz="quarter" idx="3"/>
           </p:nvPr>
         </p:nvSpPr>
         <p:spPr/>
@@ -900,7 +918,7 @@
             <a:spLocks noGrp="1"/>
           </p:cNvSpPr>
           <p:nvPr>
-            <p:ph type="sldNum" idx="5" sz="quarter"/>
+            <p:ph type="sldNum" sz="quarter" idx="5"/>
           </p:nvPr>
         </p:nvSpPr>
         <p:spPr/>
@@ -914,7 +932,7 @@
 </file>
 
 <file path=ppt/notesSlides/notesSlide15.xml><?xml version="1.0" encoding="utf-8"?>
-<p:notes xmlns:a="http://schemas.openxmlformats.org/drawingml/2006/main" xmlns:p="http://schemas.openxmlformats.org/presentationml/2006/main" xmlns:r="http://schemas.openxmlformats.org/officeDocument/2006/relationships">
+<p:notes xmlns:a="http://schemas.openxmlformats.org/drawingml/2006/main" xmlns:r="http://schemas.openxmlformats.org/officeDocument/2006/relationships" xmlns:p="http://schemas.openxmlformats.org/presentationml/2006/main">
   <p:cSld>
     <p:spTree>
       <p:nvGrpSpPr>
@@ -934,7 +952,7 @@
         <p:nvSpPr>
           <p:cNvPr id="2" name="Slide Image Placeholder 1"/>
           <p:cNvSpPr>
-            <a:spLocks noGrp="1"/>
+            <a:spLocks noGrp="1" noRot="1" noChangeAspect="1"/>
           </p:cNvSpPr>
           <p:nvPr>
             <p:ph type="sldImg" idx="2"/>
@@ -949,7 +967,7 @@
             <a:spLocks noGrp="1"/>
           </p:cNvSpPr>
           <p:nvPr>
-            <p:ph type="body" idx="3" sz="quarter"/>
+            <p:ph type="body" sz="quarter" idx="3"/>
           </p:nvPr>
         </p:nvSpPr>
         <p:spPr/>
@@ -970,7 +988,7 @@
             <a:spLocks noGrp="1"/>
           </p:cNvSpPr>
           <p:nvPr>
-            <p:ph type="sldNum" idx="5" sz="quarter"/>
+            <p:ph type="sldNum" sz="quarter" idx="5"/>
           </p:nvPr>
         </p:nvSpPr>
         <p:spPr/>
@@ -984,7 +1002,7 @@
 </file>
 
 <file path=ppt/notesSlides/notesSlide16.xml><?xml version="1.0" encoding="utf-8"?>
-<p:notes xmlns:a="http://schemas.openxmlformats.org/drawingml/2006/main" xmlns:p="http://schemas.openxmlformats.org/presentationml/2006/main" xmlns:r="http://schemas.openxmlformats.org/officeDocument/2006/relationships">
+<p:notes xmlns:a="http://schemas.openxmlformats.org/drawingml/2006/main" xmlns:r="http://schemas.openxmlformats.org/officeDocument/2006/relationships" xmlns:p="http://schemas.openxmlformats.org/presentationml/2006/main">
   <p:cSld>
     <p:spTree>
       <p:nvGrpSpPr>
@@ -1004,7 +1022,7 @@
         <p:nvSpPr>
           <p:cNvPr id="2" name="Slide Image Placeholder 1"/>
           <p:cNvSpPr>
-            <a:spLocks noGrp="1"/>
+            <a:spLocks noGrp="1" noRot="1" noChangeAspect="1"/>
           </p:cNvSpPr>
           <p:nvPr>
             <p:ph type="sldImg" idx="2"/>
@@ -1019,7 +1037,7 @@
             <a:spLocks noGrp="1"/>
           </p:cNvSpPr>
           <p:nvPr>
-            <p:ph type="body" idx="3" sz="quarter"/>
+            <p:ph type="body" sz="quarter" idx="3"/>
           </p:nvPr>
         </p:nvSpPr>
         <p:spPr/>
@@ -1040,7 +1058,7 @@
             <a:spLocks noGrp="1"/>
           </p:cNvSpPr>
           <p:nvPr>
-            <p:ph type="sldNum" idx="5" sz="quarter"/>
+            <p:ph type="sldNum" sz="quarter" idx="5"/>
           </p:nvPr>
         </p:nvSpPr>
         <p:spPr/>
@@ -1054,7 +1072,7 @@
 </file>
 
 <file path=ppt/notesSlides/notesSlide17.xml><?xml version="1.0" encoding="utf-8"?>
-<p:notes xmlns:a="http://schemas.openxmlformats.org/drawingml/2006/main" xmlns:p="http://schemas.openxmlformats.org/presentationml/2006/main" xmlns:r="http://schemas.openxmlformats.org/officeDocument/2006/relationships">
+<p:notes xmlns:a="http://schemas.openxmlformats.org/drawingml/2006/main" xmlns:r="http://schemas.openxmlformats.org/officeDocument/2006/relationships" xmlns:p="http://schemas.openxmlformats.org/presentationml/2006/main">
   <p:cSld>
     <p:spTree>
       <p:nvGrpSpPr>
@@ -1074,7 +1092,7 @@
         <p:nvSpPr>
           <p:cNvPr id="2" name="Slide Image Placeholder 1"/>
           <p:cNvSpPr>
-            <a:spLocks noGrp="1"/>
+            <a:spLocks noGrp="1" noRot="1" noChangeAspect="1"/>
           </p:cNvSpPr>
           <p:nvPr>
             <p:ph type="sldImg" idx="2"/>
@@ -1089,7 +1107,7 @@
             <a:spLocks noGrp="1"/>
           </p:cNvSpPr>
           <p:nvPr>
-            <p:ph type="body" idx="3" sz="quarter"/>
+            <p:ph type="body" sz="quarter" idx="3"/>
           </p:nvPr>
         </p:nvSpPr>
         <p:spPr/>
@@ -1110,7 +1128,7 @@
             <a:spLocks noGrp="1"/>
           </p:cNvSpPr>
           <p:nvPr>
-            <p:ph type="sldNum" idx="5" sz="quarter"/>
+            <p:ph type="sldNum" sz="quarter" idx="5"/>
           </p:nvPr>
         </p:nvSpPr>
         <p:spPr/>
@@ -1124,7 +1142,7 @@
 </file>
 
 <file path=ppt/notesSlides/notesSlide18.xml><?xml version="1.0" encoding="utf-8"?>
-<p:notes xmlns:a="http://schemas.openxmlformats.org/drawingml/2006/main" xmlns:p="http://schemas.openxmlformats.org/presentationml/2006/main" xmlns:r="http://schemas.openxmlformats.org/officeDocument/2006/relationships">
+<p:notes xmlns:a="http://schemas.openxmlformats.org/drawingml/2006/main" xmlns:r="http://schemas.openxmlformats.org/officeDocument/2006/relationships" xmlns:p="http://schemas.openxmlformats.org/presentationml/2006/main">
   <p:cSld>
     <p:spTree>
       <p:nvGrpSpPr>
@@ -1144,7 +1162,7 @@
         <p:nvSpPr>
           <p:cNvPr id="2" name="Slide Image Placeholder 1"/>
           <p:cNvSpPr>
-            <a:spLocks noGrp="1"/>
+            <a:spLocks noGrp="1" noRot="1" noChangeAspect="1"/>
           </p:cNvSpPr>
           <p:nvPr>
             <p:ph type="sldImg" idx="2"/>
@@ -1159,7 +1177,7 @@
             <a:spLocks noGrp="1"/>
           </p:cNvSpPr>
           <p:nvPr>
-            <p:ph type="body" idx="3" sz="quarter"/>
+            <p:ph type="body" sz="quarter" idx="3"/>
           </p:nvPr>
         </p:nvSpPr>
         <p:spPr/>
@@ -1180,7 +1198,7 @@
             <a:spLocks noGrp="1"/>
           </p:cNvSpPr>
           <p:nvPr>
-            <p:ph type="sldNum" idx="5" sz="quarter"/>
+            <p:ph type="sldNum" sz="quarter" idx="5"/>
           </p:nvPr>
         </p:nvSpPr>
         <p:spPr/>
@@ -1194,7 +1212,7 @@
 </file>
 
 <file path=ppt/notesSlides/notesSlide19.xml><?xml version="1.0" encoding="utf-8"?>
-<p:notes xmlns:a="http://schemas.openxmlformats.org/drawingml/2006/main" xmlns:p="http://schemas.openxmlformats.org/presentationml/2006/main" xmlns:r="http://schemas.openxmlformats.org/officeDocument/2006/relationships">
+<p:notes xmlns:a="http://schemas.openxmlformats.org/drawingml/2006/main" xmlns:r="http://schemas.openxmlformats.org/officeDocument/2006/relationships" xmlns:p="http://schemas.openxmlformats.org/presentationml/2006/main">
   <p:cSld>
     <p:spTree>
       <p:nvGrpSpPr>
@@ -1214,7 +1232,7 @@
         <p:nvSpPr>
           <p:cNvPr id="2" name="Slide Image Placeholder 1"/>
           <p:cNvSpPr>
-            <a:spLocks noGrp="1"/>
+            <a:spLocks noGrp="1" noRot="1" noChangeAspect="1"/>
           </p:cNvSpPr>
           <p:nvPr>
             <p:ph type="sldImg" idx="2"/>
@@ -1229,7 +1247,7 @@
             <a:spLocks noGrp="1"/>
           </p:cNvSpPr>
           <p:nvPr>
-            <p:ph type="body" idx="3" sz="quarter"/>
+            <p:ph type="body" sz="quarter" idx="3"/>
           </p:nvPr>
         </p:nvSpPr>
         <p:spPr/>
@@ -1250,7 +1268,7 @@
             <a:spLocks noGrp="1"/>
           </p:cNvSpPr>
           <p:nvPr>
-            <p:ph type="sldNum" idx="5" sz="quarter"/>
+            <p:ph type="sldNum" sz="quarter" idx="5"/>
           </p:nvPr>
         </p:nvSpPr>
         <p:spPr/>
@@ -1264,7 +1282,7 @@
 </file>
 
 <file path=ppt/notesSlides/notesSlide2.xml><?xml version="1.0" encoding="utf-8"?>
-<p:notes xmlns:a="http://schemas.openxmlformats.org/drawingml/2006/main" xmlns:p="http://schemas.openxmlformats.org/presentationml/2006/main" xmlns:r="http://schemas.openxmlformats.org/officeDocument/2006/relationships">
+<p:notes xmlns:a="http://schemas.openxmlformats.org/drawingml/2006/main" xmlns:r="http://schemas.openxmlformats.org/officeDocument/2006/relationships" xmlns:p="http://schemas.openxmlformats.org/presentationml/2006/main">
   <p:cSld>
     <p:spTree>
       <p:nvGrpSpPr>
@@ -1284,7 +1302,7 @@
         <p:nvSpPr>
           <p:cNvPr id="2" name="Slide Image Placeholder 1"/>
           <p:cNvSpPr>
-            <a:spLocks noGrp="1"/>
+            <a:spLocks noGrp="1" noRot="1" noChangeAspect="1"/>
           </p:cNvSpPr>
           <p:nvPr>
             <p:ph type="sldImg" idx="2"/>
@@ -1299,7 +1317,7 @@
             <a:spLocks noGrp="1"/>
           </p:cNvSpPr>
           <p:nvPr>
-            <p:ph type="body" idx="3" sz="quarter"/>
+            <p:ph type="body" sz="quarter" idx="3"/>
           </p:nvPr>
         </p:nvSpPr>
         <p:spPr/>
@@ -1320,7 +1338,7 @@
             <a:spLocks noGrp="1"/>
           </p:cNvSpPr>
           <p:nvPr>
-            <p:ph type="sldNum" idx="5" sz="quarter"/>
+            <p:ph type="sldNum" sz="quarter" idx="5"/>
           </p:nvPr>
         </p:nvSpPr>
         <p:spPr/>
@@ -1334,7 +1352,7 @@
 </file>
 
 <file path=ppt/notesSlides/notesSlide20.xml><?xml version="1.0" encoding="utf-8"?>
-<p:notes xmlns:a="http://schemas.openxmlformats.org/drawingml/2006/main" xmlns:p="http://schemas.openxmlformats.org/presentationml/2006/main" xmlns:r="http://schemas.openxmlformats.org/officeDocument/2006/relationships">
+<p:notes xmlns:a="http://schemas.openxmlformats.org/drawingml/2006/main" xmlns:r="http://schemas.openxmlformats.org/officeDocument/2006/relationships" xmlns:p="http://schemas.openxmlformats.org/presentationml/2006/main">
   <p:cSld>
     <p:spTree>
       <p:nvGrpSpPr>
@@ -1354,7 +1372,7 @@
         <p:nvSpPr>
           <p:cNvPr id="2" name="Slide Image Placeholder 1"/>
           <p:cNvSpPr>
-            <a:spLocks noGrp="1"/>
+            <a:spLocks noGrp="1" noRot="1" noChangeAspect="1"/>
           </p:cNvSpPr>
           <p:nvPr>
             <p:ph type="sldImg" idx="2"/>
@@ -1369,7 +1387,7 @@
             <a:spLocks noGrp="1"/>
           </p:cNvSpPr>
           <p:nvPr>
-            <p:ph type="body" idx="3" sz="quarter"/>
+            <p:ph type="body" sz="quarter" idx="3"/>
           </p:nvPr>
         </p:nvSpPr>
         <p:spPr/>
@@ -1390,7 +1408,7 @@
             <a:spLocks noGrp="1"/>
           </p:cNvSpPr>
           <p:nvPr>
-            <p:ph type="sldNum" idx="5" sz="quarter"/>
+            <p:ph type="sldNum" sz="quarter" idx="5"/>
           </p:nvPr>
         </p:nvSpPr>
         <p:spPr/>
@@ -1404,7 +1422,7 @@
 </file>
 
 <file path=ppt/notesSlides/notesSlide21.xml><?xml version="1.0" encoding="utf-8"?>
-<p:notes xmlns:a="http://schemas.openxmlformats.org/drawingml/2006/main" xmlns:p="http://schemas.openxmlformats.org/presentationml/2006/main" xmlns:r="http://schemas.openxmlformats.org/officeDocument/2006/relationships">
+<p:notes xmlns:a="http://schemas.openxmlformats.org/drawingml/2006/main" xmlns:r="http://schemas.openxmlformats.org/officeDocument/2006/relationships" xmlns:p="http://schemas.openxmlformats.org/presentationml/2006/main">
   <p:cSld>
     <p:spTree>
       <p:nvGrpSpPr>
@@ -1424,7 +1442,7 @@
         <p:nvSpPr>
           <p:cNvPr id="2" name="Slide Image Placeholder 1"/>
           <p:cNvSpPr>
-            <a:spLocks noGrp="1"/>
+            <a:spLocks noGrp="1" noRot="1" noChangeAspect="1"/>
           </p:cNvSpPr>
           <p:nvPr>
             <p:ph type="sldImg" idx="2"/>
@@ -1439,7 +1457,7 @@
             <a:spLocks noGrp="1"/>
           </p:cNvSpPr>
           <p:nvPr>
-            <p:ph type="body" idx="3" sz="quarter"/>
+            <p:ph type="body" sz="quarter" idx="3"/>
           </p:nvPr>
         </p:nvSpPr>
         <p:spPr/>
@@ -1460,7 +1478,7 @@
             <a:spLocks noGrp="1"/>
           </p:cNvSpPr>
           <p:nvPr>
-            <p:ph type="sldNum" idx="5" sz="quarter"/>
+            <p:ph type="sldNum" sz="quarter" idx="5"/>
           </p:nvPr>
         </p:nvSpPr>
         <p:spPr/>
@@ -1474,7 +1492,7 @@
 </file>
 
 <file path=ppt/notesSlides/notesSlide22.xml><?xml version="1.0" encoding="utf-8"?>
-<p:notes xmlns:a="http://schemas.openxmlformats.org/drawingml/2006/main" xmlns:p="http://schemas.openxmlformats.org/presentationml/2006/main" xmlns:r="http://schemas.openxmlformats.org/officeDocument/2006/relationships">
+<p:notes xmlns:a="http://schemas.openxmlformats.org/drawingml/2006/main" xmlns:r="http://schemas.openxmlformats.org/officeDocument/2006/relationships" xmlns:p="http://schemas.openxmlformats.org/presentationml/2006/main">
   <p:cSld>
     <p:spTree>
       <p:nvGrpSpPr>
@@ -1494,7 +1512,7 @@
         <p:nvSpPr>
           <p:cNvPr id="2" name="Slide Image Placeholder 1"/>
           <p:cNvSpPr>
-            <a:spLocks noGrp="1"/>
+            <a:spLocks noGrp="1" noRot="1" noChangeAspect="1"/>
           </p:cNvSpPr>
           <p:nvPr>
             <p:ph type="sldImg" idx="2"/>
@@ -1509,7 +1527,7 @@
             <a:spLocks noGrp="1"/>
           </p:cNvSpPr>
           <p:nvPr>
-            <p:ph type="body" idx="3" sz="quarter"/>
+            <p:ph type="body" sz="quarter" idx="3"/>
           </p:nvPr>
         </p:nvSpPr>
         <p:spPr/>
@@ -1530,7 +1548,7 @@
             <a:spLocks noGrp="1"/>
           </p:cNvSpPr>
           <p:nvPr>
-            <p:ph type="sldNum" idx="5" sz="quarter"/>
+            <p:ph type="sldNum" sz="quarter" idx="5"/>
           </p:nvPr>
         </p:nvSpPr>
         <p:spPr/>
@@ -1544,7 +1562,7 @@
 </file>
 
 <file path=ppt/notesSlides/notesSlide23.xml><?xml version="1.0" encoding="utf-8"?>
-<p:notes xmlns:a="http://schemas.openxmlformats.org/drawingml/2006/main" xmlns:p="http://schemas.openxmlformats.org/presentationml/2006/main" xmlns:r="http://schemas.openxmlformats.org/officeDocument/2006/relationships">
+<p:notes xmlns:a="http://schemas.openxmlformats.org/drawingml/2006/main" xmlns:r="http://schemas.openxmlformats.org/officeDocument/2006/relationships" xmlns:p="http://schemas.openxmlformats.org/presentationml/2006/main">
   <p:cSld>
     <p:spTree>
       <p:nvGrpSpPr>
@@ -1564,7 +1582,7 @@
         <p:nvSpPr>
           <p:cNvPr id="2" name="Slide Image Placeholder 1"/>
           <p:cNvSpPr>
-            <a:spLocks noGrp="1"/>
+            <a:spLocks noGrp="1" noRot="1" noChangeAspect="1"/>
           </p:cNvSpPr>
           <p:nvPr>
             <p:ph type="sldImg" idx="2"/>
@@ -1579,7 +1597,7 @@
             <a:spLocks noGrp="1"/>
           </p:cNvSpPr>
           <p:nvPr>
-            <p:ph type="body" idx="3" sz="quarter"/>
+            <p:ph type="body" sz="quarter" idx="3"/>
           </p:nvPr>
         </p:nvSpPr>
         <p:spPr/>
@@ -1600,7 +1618,7 @@
             <a:spLocks noGrp="1"/>
           </p:cNvSpPr>
           <p:nvPr>
-            <p:ph type="sldNum" idx="5" sz="quarter"/>
+            <p:ph type="sldNum" sz="quarter" idx="5"/>
           </p:nvPr>
         </p:nvSpPr>
         <p:spPr/>
@@ -1614,7 +1632,7 @@
 </file>
 
 <file path=ppt/notesSlides/notesSlide24.xml><?xml version="1.0" encoding="utf-8"?>
-<p:notes xmlns:a="http://schemas.openxmlformats.org/drawingml/2006/main" xmlns:p="http://schemas.openxmlformats.org/presentationml/2006/main" xmlns:r="http://schemas.openxmlformats.org/officeDocument/2006/relationships">
+<p:notes xmlns:a="http://schemas.openxmlformats.org/drawingml/2006/main" xmlns:r="http://schemas.openxmlformats.org/officeDocument/2006/relationships" xmlns:p="http://schemas.openxmlformats.org/presentationml/2006/main">
   <p:cSld>
     <p:spTree>
       <p:nvGrpSpPr>
@@ -1634,7 +1652,7 @@
         <p:nvSpPr>
           <p:cNvPr id="2" name="Slide Image Placeholder 1"/>
           <p:cNvSpPr>
-            <a:spLocks noGrp="1"/>
+            <a:spLocks noGrp="1" noRot="1" noChangeAspect="1"/>
           </p:cNvSpPr>
           <p:nvPr>
             <p:ph type="sldImg" idx="2"/>
@@ -1649,7 +1667,7 @@
             <a:spLocks noGrp="1"/>
           </p:cNvSpPr>
           <p:nvPr>
-            <p:ph type="body" idx="3" sz="quarter"/>
+            <p:ph type="body" sz="quarter" idx="3"/>
           </p:nvPr>
         </p:nvSpPr>
         <p:spPr/>
@@ -1670,7 +1688,7 @@
             <a:spLocks noGrp="1"/>
           </p:cNvSpPr>
           <p:nvPr>
-            <p:ph type="sldNum" idx="5" sz="quarter"/>
+            <p:ph type="sldNum" sz="quarter" idx="5"/>
           </p:nvPr>
         </p:nvSpPr>
         <p:spPr/>
@@ -1684,7 +1702,7 @@
 </file>
 
 <file path=ppt/notesSlides/notesSlide25.xml><?xml version="1.0" encoding="utf-8"?>
-<p:notes xmlns:a="http://schemas.openxmlformats.org/drawingml/2006/main" xmlns:p="http://schemas.openxmlformats.org/presentationml/2006/main" xmlns:r="http://schemas.openxmlformats.org/officeDocument/2006/relationships">
+<p:notes xmlns:a="http://schemas.openxmlformats.org/drawingml/2006/main" xmlns:r="http://schemas.openxmlformats.org/officeDocument/2006/relationships" xmlns:p="http://schemas.openxmlformats.org/presentationml/2006/main">
   <p:cSld>
     <p:spTree>
       <p:nvGrpSpPr>
@@ -1704,7 +1722,7 @@
         <p:nvSpPr>
           <p:cNvPr id="2" name="Slide Image Placeholder 1"/>
           <p:cNvSpPr>
-            <a:spLocks noGrp="1"/>
+            <a:spLocks noGrp="1" noRot="1" noChangeAspect="1"/>
           </p:cNvSpPr>
           <p:nvPr>
             <p:ph type="sldImg" idx="2"/>
@@ -1719,7 +1737,7 @@
             <a:spLocks noGrp="1"/>
           </p:cNvSpPr>
           <p:nvPr>
-            <p:ph type="body" idx="3" sz="quarter"/>
+            <p:ph type="body" sz="quarter" idx="3"/>
           </p:nvPr>
         </p:nvSpPr>
         <p:spPr/>
@@ -1740,7 +1758,7 @@
             <a:spLocks noGrp="1"/>
           </p:cNvSpPr>
           <p:nvPr>
-            <p:ph type="sldNum" idx="5" sz="quarter"/>
+            <p:ph type="sldNum" sz="quarter" idx="5"/>
           </p:nvPr>
         </p:nvSpPr>
         <p:spPr/>
@@ -1754,7 +1772,7 @@
 </file>
 
 <file path=ppt/notesSlides/notesSlide3.xml><?xml version="1.0" encoding="utf-8"?>
-<p:notes xmlns:a="http://schemas.openxmlformats.org/drawingml/2006/main" xmlns:p="http://schemas.openxmlformats.org/presentationml/2006/main" xmlns:r="http://schemas.openxmlformats.org/officeDocument/2006/relationships">
+<p:notes xmlns:a="http://schemas.openxmlformats.org/drawingml/2006/main" xmlns:r="http://schemas.openxmlformats.org/officeDocument/2006/relationships" xmlns:p="http://schemas.openxmlformats.org/presentationml/2006/main">
   <p:cSld>
     <p:spTree>
       <p:nvGrpSpPr>
@@ -1774,7 +1792,7 @@
         <p:nvSpPr>
           <p:cNvPr id="2" name="Slide Image Placeholder 1"/>
           <p:cNvSpPr>
-            <a:spLocks noGrp="1"/>
+            <a:spLocks noGrp="1" noRot="1" noChangeAspect="1"/>
           </p:cNvSpPr>
           <p:nvPr>
             <p:ph type="sldImg" idx="2"/>
@@ -1789,7 +1807,7 @@
             <a:spLocks noGrp="1"/>
           </p:cNvSpPr>
           <p:nvPr>
-            <p:ph type="body" idx="3" sz="quarter"/>
+            <p:ph type="body" sz="quarter" idx="3"/>
           </p:nvPr>
         </p:nvSpPr>
         <p:spPr/>
@@ -1810,7 +1828,7 @@
             <a:spLocks noGrp="1"/>
           </p:cNvSpPr>
           <p:nvPr>
-            <p:ph type="sldNum" idx="5" sz="quarter"/>
+            <p:ph type="sldNum" sz="quarter" idx="5"/>
           </p:nvPr>
         </p:nvSpPr>
         <p:spPr/>
@@ -1824,7 +1842,7 @@
 </file>
 
 <file path=ppt/notesSlides/notesSlide4.xml><?xml version="1.0" encoding="utf-8"?>
-<p:notes xmlns:a="http://schemas.openxmlformats.org/drawingml/2006/main" xmlns:p="http://schemas.openxmlformats.org/presentationml/2006/main" xmlns:r="http://schemas.openxmlformats.org/officeDocument/2006/relationships">
+<p:notes xmlns:a="http://schemas.openxmlformats.org/drawingml/2006/main" xmlns:r="http://schemas.openxmlformats.org/officeDocument/2006/relationships" xmlns:p="http://schemas.openxmlformats.org/presentationml/2006/main">
   <p:cSld>
     <p:spTree>
       <p:nvGrpSpPr>
@@ -1844,7 +1862,7 @@
         <p:nvSpPr>
           <p:cNvPr id="2" name="Slide Image Placeholder 1"/>
           <p:cNvSpPr>
-            <a:spLocks noGrp="1"/>
+            <a:spLocks noGrp="1" noRot="1" noChangeAspect="1"/>
           </p:cNvSpPr>
           <p:nvPr>
             <p:ph type="sldImg" idx="2"/>
@@ -1859,7 +1877,7 @@
             <a:spLocks noGrp="1"/>
           </p:cNvSpPr>
           <p:nvPr>
-            <p:ph type="body" idx="3" sz="quarter"/>
+            <p:ph type="body" sz="quarter" idx="3"/>
           </p:nvPr>
         </p:nvSpPr>
         <p:spPr/>
@@ -1880,7 +1898,7 @@
             <a:spLocks noGrp="1"/>
           </p:cNvSpPr>
           <p:nvPr>
-            <p:ph type="sldNum" idx="5" sz="quarter"/>
+            <p:ph type="sldNum" sz="quarter" idx="5"/>
           </p:nvPr>
         </p:nvSpPr>
         <p:spPr/>
@@ -1894,7 +1912,7 @@
 </file>
 
 <file path=ppt/notesSlides/notesSlide5.xml><?xml version="1.0" encoding="utf-8"?>
-<p:notes xmlns:a="http://schemas.openxmlformats.org/drawingml/2006/main" xmlns:p="http://schemas.openxmlformats.org/presentationml/2006/main" xmlns:r="http://schemas.openxmlformats.org/officeDocument/2006/relationships">
+<p:notes xmlns:a="http://schemas.openxmlformats.org/drawingml/2006/main" xmlns:r="http://schemas.openxmlformats.org/officeDocument/2006/relationships" xmlns:p="http://schemas.openxmlformats.org/presentationml/2006/main">
   <p:cSld>
     <p:spTree>
       <p:nvGrpSpPr>
@@ -1914,7 +1932,7 @@
         <p:nvSpPr>
           <p:cNvPr id="2" name="Slide Image Placeholder 1"/>
           <p:cNvSpPr>
-            <a:spLocks noGrp="1"/>
+            <a:spLocks noGrp="1" noRot="1" noChangeAspect="1"/>
           </p:cNvSpPr>
           <p:nvPr>
             <p:ph type="sldImg" idx="2"/>
@@ -1929,7 +1947,7 @@
             <a:spLocks noGrp="1"/>
           </p:cNvSpPr>
           <p:nvPr>
-            <p:ph type="body" idx="3" sz="quarter"/>
+            <p:ph type="body" sz="quarter" idx="3"/>
           </p:nvPr>
         </p:nvSpPr>
         <p:spPr/>
@@ -1950,7 +1968,7 @@
             <a:spLocks noGrp="1"/>
           </p:cNvSpPr>
           <p:nvPr>
-            <p:ph type="sldNum" idx="5" sz="quarter"/>
+            <p:ph type="sldNum" sz="quarter" idx="5"/>
           </p:nvPr>
         </p:nvSpPr>
         <p:spPr/>
@@ -1964,7 +1982,7 @@
 </file>
 
 <file path=ppt/notesSlides/notesSlide6.xml><?xml version="1.0" encoding="utf-8"?>
-<p:notes xmlns:a="http://schemas.openxmlformats.org/drawingml/2006/main" xmlns:p="http://schemas.openxmlformats.org/presentationml/2006/main" xmlns:r="http://schemas.openxmlformats.org/officeDocument/2006/relationships">
+<p:notes xmlns:a="http://schemas.openxmlformats.org/drawingml/2006/main" xmlns:r="http://schemas.openxmlformats.org/officeDocument/2006/relationships" xmlns:p="http://schemas.openxmlformats.org/presentationml/2006/main">
   <p:cSld>
     <p:spTree>
       <p:nvGrpSpPr>
@@ -1984,7 +2002,7 @@
         <p:nvSpPr>
           <p:cNvPr id="2" name="Slide Image Placeholder 1"/>
           <p:cNvSpPr>
-            <a:spLocks noGrp="1"/>
+            <a:spLocks noGrp="1" noRot="1" noChangeAspect="1"/>
           </p:cNvSpPr>
           <p:nvPr>
             <p:ph type="sldImg" idx="2"/>
@@ -1999,7 +2017,7 @@
             <a:spLocks noGrp="1"/>
           </p:cNvSpPr>
           <p:nvPr>
-            <p:ph type="body" idx="3" sz="quarter"/>
+            <p:ph type="body" sz="quarter" idx="3"/>
           </p:nvPr>
         </p:nvSpPr>
         <p:spPr/>
@@ -2020,7 +2038,7 @@
             <a:spLocks noGrp="1"/>
           </p:cNvSpPr>
           <p:nvPr>
-            <p:ph type="sldNum" idx="5" sz="quarter"/>
+            <p:ph type="sldNum" sz="quarter" idx="5"/>
           </p:nvPr>
         </p:nvSpPr>
         <p:spPr/>
@@ -2034,7 +2052,7 @@
 </file>
 
 <file path=ppt/notesSlides/notesSlide7.xml><?xml version="1.0" encoding="utf-8"?>
-<p:notes xmlns:a="http://schemas.openxmlformats.org/drawingml/2006/main" xmlns:p="http://schemas.openxmlformats.org/presentationml/2006/main" xmlns:r="http://schemas.openxmlformats.org/officeDocument/2006/relationships">
+<p:notes xmlns:a="http://schemas.openxmlformats.org/drawingml/2006/main" xmlns:r="http://schemas.openxmlformats.org/officeDocument/2006/relationships" xmlns:p="http://schemas.openxmlformats.org/presentationml/2006/main">
   <p:cSld>
     <p:spTree>
       <p:nvGrpSpPr>
@@ -2054,7 +2072,7 @@
         <p:nvSpPr>
           <p:cNvPr id="2" name="Slide Image Placeholder 1"/>
           <p:cNvSpPr>
-            <a:spLocks noGrp="1"/>
+            <a:spLocks noGrp="1" noRot="1" noChangeAspect="1"/>
           </p:cNvSpPr>
           <p:nvPr>
             <p:ph type="sldImg" idx="2"/>
@@ -2069,7 +2087,7 @@
             <a:spLocks noGrp="1"/>
           </p:cNvSpPr>
           <p:nvPr>
-            <p:ph type="body" idx="3" sz="quarter"/>
+            <p:ph type="body" sz="quarter" idx="3"/>
           </p:nvPr>
         </p:nvSpPr>
         <p:spPr/>
@@ -2090,7 +2108,7 @@
             <a:spLocks noGrp="1"/>
           </p:cNvSpPr>
           <p:nvPr>
-            <p:ph type="sldNum" idx="5" sz="quarter"/>
+            <p:ph type="sldNum" sz="quarter" idx="5"/>
           </p:nvPr>
         </p:nvSpPr>
         <p:spPr/>
@@ -2104,7 +2122,7 @@
 </file>
 
 <file path=ppt/notesSlides/notesSlide8.xml><?xml version="1.0" encoding="utf-8"?>
-<p:notes xmlns:a="http://schemas.openxmlformats.org/drawingml/2006/main" xmlns:p="http://schemas.openxmlformats.org/presentationml/2006/main" xmlns:r="http://schemas.openxmlformats.org/officeDocument/2006/relationships">
+<p:notes xmlns:a="http://schemas.openxmlformats.org/drawingml/2006/main" xmlns:r="http://schemas.openxmlformats.org/officeDocument/2006/relationships" xmlns:p="http://schemas.openxmlformats.org/presentationml/2006/main">
   <p:cSld>
     <p:spTree>
       <p:nvGrpSpPr>
@@ -2124,7 +2142,7 @@
         <p:nvSpPr>
           <p:cNvPr id="2" name="Slide Image Placeholder 1"/>
           <p:cNvSpPr>
-            <a:spLocks noGrp="1"/>
+            <a:spLocks noGrp="1" noRot="1" noChangeAspect="1"/>
           </p:cNvSpPr>
           <p:nvPr>
             <p:ph type="sldImg" idx="2"/>
@@ -2139,7 +2157,7 @@
             <a:spLocks noGrp="1"/>
           </p:cNvSpPr>
           <p:nvPr>
-            <p:ph type="body" idx="3" sz="quarter"/>
+            <p:ph type="body" sz="quarter" idx="3"/>
           </p:nvPr>
         </p:nvSpPr>
         <p:spPr/>
@@ -2160,7 +2178,7 @@
             <a:spLocks noGrp="1"/>
           </p:cNvSpPr>
           <p:nvPr>
-            <p:ph type="sldNum" idx="5" sz="quarter"/>
+            <p:ph type="sldNum" sz="quarter" idx="5"/>
           </p:nvPr>
         </p:nvSpPr>
         <p:spPr/>
@@ -2174,7 +2192,7 @@
 </file>
 
 <file path=ppt/notesSlides/notesSlide9.xml><?xml version="1.0" encoding="utf-8"?>
-<p:notes xmlns:a="http://schemas.openxmlformats.org/drawingml/2006/main" xmlns:p="http://schemas.openxmlformats.org/presentationml/2006/main" xmlns:r="http://schemas.openxmlformats.org/officeDocument/2006/relationships">
+<p:notes xmlns:a="http://schemas.openxmlformats.org/drawingml/2006/main" xmlns:r="http://schemas.openxmlformats.org/officeDocument/2006/relationships" xmlns:p="http://schemas.openxmlformats.org/presentationml/2006/main">
   <p:cSld>
     <p:spTree>
       <p:nvGrpSpPr>
@@ -2194,7 +2212,7 @@
         <p:nvSpPr>
           <p:cNvPr id="2" name="Slide Image Placeholder 1"/>
           <p:cNvSpPr>
-            <a:spLocks noGrp="1"/>
+            <a:spLocks noGrp="1" noRot="1" noChangeAspect="1"/>
           </p:cNvSpPr>
           <p:nvPr>
             <p:ph type="sldImg" idx="2"/>
@@ -2209,7 +2227,7 @@
             <a:spLocks noGrp="1"/>
           </p:cNvSpPr>
           <p:nvPr>
-            <p:ph type="body" idx="3" sz="quarter"/>
+            <p:ph type="body" sz="quarter" idx="3"/>
           </p:nvPr>
         </p:nvSpPr>
         <p:spPr/>
@@ -2230,7 +2248,7 @@
             <a:spLocks noGrp="1"/>
           </p:cNvSpPr>
           <p:nvPr>
-            <p:ph type="sldNum" idx="5" sz="quarter"/>
+            <p:ph type="sldNum" sz="quarter" idx="5"/>
           </p:nvPr>
         </p:nvSpPr>
         <p:spPr/>
@@ -2281,10 +2299,9 @@
           <a:lstStyle/>
           <a:p>
             <a:r>
-              <a:rPr lang="en-US" smtClean="0"/>
+              <a:rPr lang="en-US"/>
               <a:t>Click to edit Master title style</a:t>
             </a:r>
-            <a:endParaRPr lang="en-US"/>
           </a:p>
         </p:txBody>
       </p:sp>
@@ -2400,10 +2417,9 @@
           </a:lstStyle>
           <a:p>
             <a:r>
-              <a:rPr lang="en-US" smtClean="0"/>
+              <a:rPr lang="en-US"/>
               <a:t>Click to edit Master subtitle style</a:t>
             </a:r>
-            <a:endParaRPr lang="en-US"/>
           </a:p>
         </p:txBody>
       </p:sp>
@@ -2424,7 +2440,7 @@
           <a:p>
             <a:fld id="{5BCAD085-E8A6-8845-BD4E-CB4CCA059FC4}" type="datetimeFigureOut">
               <a:rPr lang="en-US" smtClean="0"/>
-              <a:t>1/27/13</a:t>
+              <a:t>10/29/2026</a:t>
             </a:fld>
             <a:endParaRPr lang="en-US"/>
           </a:p>
@@ -2518,10 +2534,9 @@
           <a:lstStyle/>
           <a:p>
             <a:r>
-              <a:rPr lang="en-US" smtClean="0"/>
+              <a:rPr lang="en-US"/>
               <a:t>Click to edit Master title style</a:t>
             </a:r>
-            <a:endParaRPr lang="en-US"/>
           </a:p>
         </p:txBody>
       </p:sp>
@@ -2542,38 +2557,37 @@
           <a:p>
             <a:pPr lvl="0"/>
             <a:r>
-              <a:rPr lang="en-US" smtClean="0"/>
+              <a:rPr lang="en-US"/>
               <a:t>Click to edit Master text styles</a:t>
             </a:r>
           </a:p>
           <a:p>
             <a:pPr lvl="1"/>
             <a:r>
-              <a:rPr lang="en-US" smtClean="0"/>
+              <a:rPr lang="en-US"/>
               <a:t>Second level</a:t>
             </a:r>
           </a:p>
           <a:p>
             <a:pPr lvl="2"/>
             <a:r>
-              <a:rPr lang="en-US" smtClean="0"/>
+              <a:rPr lang="en-US"/>
               <a:t>Third level</a:t>
             </a:r>
           </a:p>
           <a:p>
             <a:pPr lvl="3"/>
             <a:r>
-              <a:rPr lang="en-US" smtClean="0"/>
+              <a:rPr lang="en-US"/>
               <a:t>Fourth level</a:t>
             </a:r>
           </a:p>
           <a:p>
             <a:pPr lvl="4"/>
             <a:r>
-              <a:rPr lang="en-US" smtClean="0"/>
+              <a:rPr lang="en-US"/>
               <a:t>Fifth level</a:t>
             </a:r>
-            <a:endParaRPr lang="en-US"/>
           </a:p>
         </p:txBody>
       </p:sp>
@@ -2594,7 +2608,7 @@
           <a:p>
             <a:fld id="{5BCAD085-E8A6-8845-BD4E-CB4CCA059FC4}" type="datetimeFigureOut">
               <a:rPr lang="en-US" smtClean="0"/>
-              <a:t>1/27/13</a:t>
+              <a:t>10/29/2026</a:t>
             </a:fld>
             <a:endParaRPr lang="en-US"/>
           </a:p>
@@ -2693,10 +2707,9 @@
           <a:lstStyle/>
           <a:p>
             <a:r>
-              <a:rPr lang="en-US" smtClean="0"/>
+              <a:rPr lang="en-US"/>
               <a:t>Click to edit Master title style</a:t>
             </a:r>
-            <a:endParaRPr lang="en-US"/>
           </a:p>
         </p:txBody>
       </p:sp>
@@ -2722,38 +2735,37 @@
           <a:p>
             <a:pPr lvl="0"/>
             <a:r>
-              <a:rPr lang="en-US" smtClean="0"/>
+              <a:rPr lang="en-US"/>
               <a:t>Click to edit Master text styles</a:t>
             </a:r>
           </a:p>
           <a:p>
             <a:pPr lvl="1"/>
             <a:r>
-              <a:rPr lang="en-US" smtClean="0"/>
+              <a:rPr lang="en-US"/>
               <a:t>Second level</a:t>
             </a:r>
           </a:p>
           <a:p>
             <a:pPr lvl="2"/>
             <a:r>
-              <a:rPr lang="en-US" smtClean="0"/>
+              <a:rPr lang="en-US"/>
               <a:t>Third level</a:t>
             </a:r>
           </a:p>
           <a:p>
             <a:pPr lvl="3"/>
             <a:r>
-              <a:rPr lang="en-US" smtClean="0"/>
+              <a:rPr lang="en-US"/>
               <a:t>Fourth level</a:t>
             </a:r>
           </a:p>
           <a:p>
             <a:pPr lvl="4"/>
             <a:r>
-              <a:rPr lang="en-US" smtClean="0"/>
+              <a:rPr lang="en-US"/>
               <a:t>Fifth level</a:t>
             </a:r>
-            <a:endParaRPr lang="en-US"/>
           </a:p>
         </p:txBody>
       </p:sp>
@@ -2774,7 +2786,7 @@
           <a:p>
             <a:fld id="{5BCAD085-E8A6-8845-BD4E-CB4CCA059FC4}" type="datetimeFigureOut">
               <a:rPr lang="en-US" smtClean="0"/>
-              <a:t>1/27/13</a:t>
+              <a:t>10/29/2026</a:t>
             </a:fld>
             <a:endParaRPr lang="en-US"/>
           </a:p>
@@ -2868,10 +2880,9 @@
           <a:lstStyle/>
           <a:p>
             <a:r>
-              <a:rPr lang="en-US" smtClean="0"/>
+              <a:rPr lang="en-US"/>
               <a:t>Click to edit Master title style</a:t>
             </a:r>
-            <a:endParaRPr lang="en-US"/>
           </a:p>
         </p:txBody>
       </p:sp>
@@ -2892,38 +2903,37 @@
           <a:p>
             <a:pPr lvl="0"/>
             <a:r>
-              <a:rPr lang="en-US" smtClean="0"/>
+              <a:rPr lang="en-US"/>
               <a:t>Click to edit Master text styles</a:t>
             </a:r>
           </a:p>
           <a:p>
             <a:pPr lvl="1"/>
             <a:r>
-              <a:rPr lang="en-US" smtClean="0"/>
+              <a:rPr lang="en-US"/>
               <a:t>Second level</a:t>
             </a:r>
           </a:p>
           <a:p>
             <a:pPr lvl="2"/>
             <a:r>
-              <a:rPr lang="en-US" smtClean="0"/>
+              <a:rPr lang="en-US"/>
               <a:t>Third level</a:t>
             </a:r>
           </a:p>
           <a:p>
             <a:pPr lvl="3"/>
             <a:r>
-              <a:rPr lang="en-US" smtClean="0"/>
+              <a:rPr lang="en-US"/>
               <a:t>Fourth level</a:t>
             </a:r>
           </a:p>
           <a:p>
             <a:pPr lvl="4"/>
             <a:r>
-              <a:rPr lang="en-US" smtClean="0"/>
+              <a:rPr lang="en-US"/>
               <a:t>Fifth level</a:t>
             </a:r>
-            <a:endParaRPr lang="en-US"/>
           </a:p>
         </p:txBody>
       </p:sp>
@@ -2944,7 +2954,7 @@
           <a:p>
             <a:fld id="{5BCAD085-E8A6-8845-BD4E-CB4CCA059FC4}" type="datetimeFigureOut">
               <a:rPr lang="en-US" smtClean="0"/>
-              <a:t>1/27/13</a:t>
+              <a:t>10/29/2026</a:t>
             </a:fld>
             <a:endParaRPr lang="en-US"/>
           </a:p>
@@ -3047,10 +3057,9 @@
           </a:lstStyle>
           <a:p>
             <a:r>
-              <a:rPr lang="en-US" smtClean="0"/>
+              <a:rPr lang="en-US"/>
               <a:t>Click to edit Master title style</a:t>
             </a:r>
-            <a:endParaRPr lang="en-US"/>
           </a:p>
         </p:txBody>
       </p:sp>
@@ -3167,7 +3176,7 @@
           <a:p>
             <a:pPr lvl="0"/>
             <a:r>
-              <a:rPr lang="en-US" smtClean="0"/>
+              <a:rPr lang="en-US"/>
               <a:t>Click to edit Master text styles</a:t>
             </a:r>
           </a:p>
@@ -3190,7 +3199,7 @@
           <a:p>
             <a:fld id="{5BCAD085-E8A6-8845-BD4E-CB4CCA059FC4}" type="datetimeFigureOut">
               <a:rPr lang="en-US" smtClean="0"/>
-              <a:t>1/27/13</a:t>
+              <a:t>10/29/2026</a:t>
             </a:fld>
             <a:endParaRPr lang="en-US"/>
           </a:p>
@@ -3284,10 +3293,9 @@
           <a:lstStyle/>
           <a:p>
             <a:r>
-              <a:rPr lang="en-US" smtClean="0"/>
+              <a:rPr lang="en-US"/>
               <a:t>Click to edit Master title style</a:t>
             </a:r>
-            <a:endParaRPr lang="en-US"/>
           </a:p>
         </p:txBody>
       </p:sp>
@@ -3341,38 +3349,37 @@
           <a:p>
             <a:pPr lvl="0"/>
             <a:r>
-              <a:rPr lang="en-US" smtClean="0"/>
+              <a:rPr lang="en-US"/>
               <a:t>Click to edit Master text styles</a:t>
             </a:r>
           </a:p>
           <a:p>
             <a:pPr lvl="1"/>
             <a:r>
-              <a:rPr lang="en-US" smtClean="0"/>
+              <a:rPr lang="en-US"/>
               <a:t>Second level</a:t>
             </a:r>
           </a:p>
           <a:p>
             <a:pPr lvl="2"/>
             <a:r>
-              <a:rPr lang="en-US" smtClean="0"/>
+              <a:rPr lang="en-US"/>
               <a:t>Third level</a:t>
             </a:r>
           </a:p>
           <a:p>
             <a:pPr lvl="3"/>
             <a:r>
-              <a:rPr lang="en-US" smtClean="0"/>
+              <a:rPr lang="en-US"/>
               <a:t>Fourth level</a:t>
             </a:r>
           </a:p>
           <a:p>
             <a:pPr lvl="4"/>
             <a:r>
-              <a:rPr lang="en-US" smtClean="0"/>
+              <a:rPr lang="en-US"/>
               <a:t>Fifth level</a:t>
             </a:r>
-            <a:endParaRPr lang="en-US"/>
           </a:p>
         </p:txBody>
       </p:sp>
@@ -3426,38 +3433,37 @@
           <a:p>
             <a:pPr lvl="0"/>
             <a:r>
-              <a:rPr lang="en-US" smtClean="0"/>
+              <a:rPr lang="en-US"/>
               <a:t>Click to edit Master text styles</a:t>
             </a:r>
           </a:p>
           <a:p>
             <a:pPr lvl="1"/>
             <a:r>
-              <a:rPr lang="en-US" smtClean="0"/>
+              <a:rPr lang="en-US"/>
               <a:t>Second level</a:t>
             </a:r>
           </a:p>
           <a:p>
             <a:pPr lvl="2"/>
             <a:r>
-              <a:rPr lang="en-US" smtClean="0"/>
+              <a:rPr lang="en-US"/>
               <a:t>Third level</a:t>
             </a:r>
           </a:p>
           <a:p>
             <a:pPr lvl="3"/>
             <a:r>
-              <a:rPr lang="en-US" smtClean="0"/>
+              <a:rPr lang="en-US"/>
               <a:t>Fourth level</a:t>
             </a:r>
           </a:p>
           <a:p>
             <a:pPr lvl="4"/>
             <a:r>
-              <a:rPr lang="en-US" smtClean="0"/>
+              <a:rPr lang="en-US"/>
               <a:t>Fifth level</a:t>
             </a:r>
-            <a:endParaRPr lang="en-US"/>
           </a:p>
         </p:txBody>
       </p:sp>
@@ -3478,7 +3484,7 @@
           <a:p>
             <a:fld id="{5BCAD085-E8A6-8845-BD4E-CB4CCA059FC4}" type="datetimeFigureOut">
               <a:rPr lang="en-US" smtClean="0"/>
-              <a:t>1/27/13</a:t>
+              <a:t>10/29/2026</a:t>
             </a:fld>
             <a:endParaRPr lang="en-US"/>
           </a:p>
@@ -3576,10 +3582,9 @@
           </a:lstStyle>
           <a:p>
             <a:r>
-              <a:rPr lang="en-US" smtClean="0"/>
+              <a:rPr lang="en-US"/>
               <a:t>Click to edit Master title style</a:t>
             </a:r>
-            <a:endParaRPr lang="en-US"/>
           </a:p>
         </p:txBody>
       </p:sp>
@@ -3642,7 +3647,7 @@
           <a:p>
             <a:pPr lvl="0"/>
             <a:r>
-              <a:rPr lang="en-US" smtClean="0"/>
+              <a:rPr lang="en-US"/>
               <a:t>Click to edit Master text styles</a:t>
             </a:r>
           </a:p>
@@ -3698,38 +3703,37 @@
           <a:p>
             <a:pPr lvl="0"/>
             <a:r>
-              <a:rPr lang="en-US" smtClean="0"/>
+              <a:rPr lang="en-US"/>
               <a:t>Click to edit Master text styles</a:t>
             </a:r>
           </a:p>
           <a:p>
             <a:pPr lvl="1"/>
             <a:r>
-              <a:rPr lang="en-US" smtClean="0"/>
+              <a:rPr lang="en-US"/>
               <a:t>Second level</a:t>
             </a:r>
           </a:p>
           <a:p>
             <a:pPr lvl="2"/>
             <a:r>
-              <a:rPr lang="en-US" smtClean="0"/>
+              <a:rPr lang="en-US"/>
               <a:t>Third level</a:t>
             </a:r>
           </a:p>
           <a:p>
             <a:pPr lvl="3"/>
             <a:r>
-              <a:rPr lang="en-US" smtClean="0"/>
+              <a:rPr lang="en-US"/>
               <a:t>Fourth level</a:t>
             </a:r>
           </a:p>
           <a:p>
             <a:pPr lvl="4"/>
             <a:r>
-              <a:rPr lang="en-US" smtClean="0"/>
+              <a:rPr lang="en-US"/>
               <a:t>Fifth level</a:t>
             </a:r>
-            <a:endParaRPr lang="en-US"/>
           </a:p>
         </p:txBody>
       </p:sp>
@@ -3792,7 +3796,7 @@
           <a:p>
             <a:pPr lvl="0"/>
             <a:r>
-              <a:rPr lang="en-US" smtClean="0"/>
+              <a:rPr lang="en-US"/>
               <a:t>Click to edit Master text styles</a:t>
             </a:r>
           </a:p>
@@ -3848,38 +3852,37 @@
           <a:p>
             <a:pPr lvl="0"/>
             <a:r>
-              <a:rPr lang="en-US" smtClean="0"/>
+              <a:rPr lang="en-US"/>
               <a:t>Click to edit Master text styles</a:t>
             </a:r>
           </a:p>
           <a:p>
             <a:pPr lvl="1"/>
             <a:r>
-              <a:rPr lang="en-US" smtClean="0"/>
+              <a:rPr lang="en-US"/>
               <a:t>Second level</a:t>
             </a:r>
           </a:p>
           <a:p>
             <a:pPr lvl="2"/>
             <a:r>
-              <a:rPr lang="en-US" smtClean="0"/>
+              <a:rPr lang="en-US"/>
               <a:t>Third level</a:t>
             </a:r>
           </a:p>
           <a:p>
             <a:pPr lvl="3"/>
             <a:r>
-              <a:rPr lang="en-US" smtClean="0"/>
+              <a:rPr lang="en-US"/>
               <a:t>Fourth level</a:t>
             </a:r>
           </a:p>
           <a:p>
             <a:pPr lvl="4"/>
             <a:r>
-              <a:rPr lang="en-US" smtClean="0"/>
+              <a:rPr lang="en-US"/>
               <a:t>Fifth level</a:t>
             </a:r>
-            <a:endParaRPr lang="en-US"/>
           </a:p>
         </p:txBody>
       </p:sp>
@@ -3900,7 +3903,7 @@
           <a:p>
             <a:fld id="{5BCAD085-E8A6-8845-BD4E-CB4CCA059FC4}" type="datetimeFigureOut">
               <a:rPr lang="en-US" smtClean="0"/>
-              <a:t>1/27/13</a:t>
+              <a:t>10/29/2026</a:t>
             </a:fld>
             <a:endParaRPr lang="en-US"/>
           </a:p>
@@ -3994,10 +3997,9 @@
           <a:lstStyle/>
           <a:p>
             <a:r>
-              <a:rPr lang="en-US" smtClean="0"/>
+              <a:rPr lang="en-US"/>
               <a:t>Click to edit Master title style</a:t>
             </a:r>
-            <a:endParaRPr lang="en-US"/>
           </a:p>
         </p:txBody>
       </p:sp>
@@ -4018,7 +4020,7 @@
           <a:p>
             <a:fld id="{5BCAD085-E8A6-8845-BD4E-CB4CCA059FC4}" type="datetimeFigureOut">
               <a:rPr lang="en-US" smtClean="0"/>
-              <a:t>1/27/13</a:t>
+              <a:t>10/29/2026</a:t>
             </a:fld>
             <a:endParaRPr lang="en-US"/>
           </a:p>
@@ -4113,7 +4115,7 @@
           <a:p>
             <a:fld id="{5BCAD085-E8A6-8845-BD4E-CB4CCA059FC4}" type="datetimeFigureOut">
               <a:rPr lang="en-US" smtClean="0"/>
-              <a:t>1/27/13</a:t>
+              <a:t>10/29/2026</a:t>
             </a:fld>
             <a:endParaRPr lang="en-US"/>
           </a:p>
@@ -4216,10 +4218,9 @@
           </a:lstStyle>
           <a:p>
             <a:r>
-              <a:rPr lang="en-US" smtClean="0"/>
+              <a:rPr lang="en-US"/>
               <a:t>Click to edit Master title style</a:t>
             </a:r>
-            <a:endParaRPr lang="en-US"/>
           </a:p>
         </p:txBody>
       </p:sp>
@@ -4273,38 +4274,37 @@
           <a:p>
             <a:pPr lvl="0"/>
             <a:r>
-              <a:rPr lang="en-US" smtClean="0"/>
+              <a:rPr lang="en-US"/>
               <a:t>Click to edit Master text styles</a:t>
             </a:r>
           </a:p>
           <a:p>
             <a:pPr lvl="1"/>
             <a:r>
-              <a:rPr lang="en-US" smtClean="0"/>
+              <a:rPr lang="en-US"/>
               <a:t>Second level</a:t>
             </a:r>
           </a:p>
           <a:p>
             <a:pPr lvl="2"/>
             <a:r>
-              <a:rPr lang="en-US" smtClean="0"/>
+              <a:rPr lang="en-US"/>
               <a:t>Third level</a:t>
             </a:r>
           </a:p>
           <a:p>
             <a:pPr lvl="3"/>
             <a:r>
-              <a:rPr lang="en-US" smtClean="0"/>
+              <a:rPr lang="en-US"/>
               <a:t>Fourth level</a:t>
             </a:r>
           </a:p>
           <a:p>
             <a:pPr lvl="4"/>
             <a:r>
-              <a:rPr lang="en-US" smtClean="0"/>
+              <a:rPr lang="en-US"/>
               <a:t>Fifth level</a:t>
             </a:r>
-            <a:endParaRPr lang="en-US"/>
           </a:p>
         </p:txBody>
       </p:sp>
@@ -4367,7 +4367,7 @@
           <a:p>
             <a:pPr lvl="0"/>
             <a:r>
-              <a:rPr lang="en-US" smtClean="0"/>
+              <a:rPr lang="en-US"/>
               <a:t>Click to edit Master text styles</a:t>
             </a:r>
           </a:p>
@@ -4390,7 +4390,7 @@
           <a:p>
             <a:fld id="{5BCAD085-E8A6-8845-BD4E-CB4CCA059FC4}" type="datetimeFigureOut">
               <a:rPr lang="en-US" smtClean="0"/>
-              <a:t>1/27/13</a:t>
+              <a:t>10/29/2026</a:t>
             </a:fld>
             <a:endParaRPr lang="en-US"/>
           </a:p>
@@ -4493,10 +4493,9 @@
           </a:lstStyle>
           <a:p>
             <a:r>
-              <a:rPr lang="en-US" smtClean="0"/>
+              <a:rPr lang="en-US"/>
               <a:t>Click to edit Master title style</a:t>
             </a:r>
-            <a:endParaRPr lang="en-US"/>
           </a:p>
         </p:txBody>
       </p:sp>
@@ -4620,7 +4619,7 @@
           <a:p>
             <a:pPr lvl="0"/>
             <a:r>
-              <a:rPr lang="en-US" smtClean="0"/>
+              <a:rPr lang="en-US"/>
               <a:t>Click to edit Master text styles</a:t>
             </a:r>
           </a:p>
@@ -4643,7 +4642,7 @@
           <a:p>
             <a:fld id="{5BCAD085-E8A6-8845-BD4E-CB4CCA059FC4}" type="datetimeFigureOut">
               <a:rPr lang="en-US" smtClean="0"/>
-              <a:t>1/27/13</a:t>
+              <a:t>10/29/2026</a:t>
             </a:fld>
             <a:endParaRPr lang="en-US"/>
           </a:p>
@@ -4752,10 +4751,9 @@
           <a:lstStyle/>
           <a:p>
             <a:r>
-              <a:rPr lang="en-US" smtClean="0"/>
+              <a:rPr lang="en-US"/>
               <a:t>Click to edit Master title style</a:t>
             </a:r>
-            <a:endParaRPr lang="en-US"/>
           </a:p>
         </p:txBody>
       </p:sp>
@@ -4786,38 +4784,37 @@
           <a:p>
             <a:pPr lvl="0"/>
             <a:r>
-              <a:rPr lang="en-US" smtClean="0"/>
+              <a:rPr lang="en-US"/>
               <a:t>Click to edit Master text styles</a:t>
             </a:r>
           </a:p>
           <a:p>
             <a:pPr lvl="1"/>
             <a:r>
-              <a:rPr lang="en-US" smtClean="0"/>
+              <a:rPr lang="en-US"/>
               <a:t>Second level</a:t>
             </a:r>
           </a:p>
           <a:p>
             <a:pPr lvl="2"/>
             <a:r>
-              <a:rPr lang="en-US" smtClean="0"/>
+              <a:rPr lang="en-US"/>
               <a:t>Third level</a:t>
             </a:r>
           </a:p>
           <a:p>
             <a:pPr lvl="3"/>
             <a:r>
-              <a:rPr lang="en-US" smtClean="0"/>
+              <a:rPr lang="en-US"/>
               <a:t>Fourth level</a:t>
             </a:r>
           </a:p>
           <a:p>
             <a:pPr lvl="4"/>
             <a:r>
-              <a:rPr lang="en-US" smtClean="0"/>
+              <a:rPr lang="en-US"/>
               <a:t>Fifth level</a:t>
             </a:r>
-            <a:endParaRPr lang="en-US"/>
           </a:p>
         </p:txBody>
       </p:sp>
@@ -4856,7 +4853,7 @@
           <a:p>
             <a:fld id="{5BCAD085-E8A6-8845-BD4E-CB4CCA059FC4}" type="datetimeFigureOut">
               <a:rPr lang="en-US" smtClean="0"/>
-              <a:t>1/27/13</a:t>
+              <a:t>10/29/2026</a:t>
             </a:fld>
             <a:endParaRPr lang="en-US"/>
           </a:p>
@@ -5215,7 +5212,7 @@
 </file>
 
 <file path=ppt/slides/slide1.xml><?xml version="1.0" encoding="utf-8"?>
-<p:sld xmlns:a="http://schemas.openxmlformats.org/drawingml/2006/main" xmlns:p="http://schemas.openxmlformats.org/presentationml/2006/main" xmlns:r="http://schemas.openxmlformats.org/officeDocument/2006/relationships">
+<p:sld xmlns:a="http://schemas.openxmlformats.org/drawingml/2006/main" xmlns:r="http://schemas.openxmlformats.org/officeDocument/2006/relationships" xmlns:p="http://schemas.openxmlformats.org/presentationml/2006/main">
   <p:cSld>
     <p:spTree>
       <p:nvGrpSpPr>
@@ -5223,7 +5220,14 @@
         <p:cNvGrpSpPr/>
         <p:nvPr/>
       </p:nvGrpSpPr>
-      <p:grpSpPr/>
+      <p:grpSpPr>
+        <a:xfrm>
+          <a:off x="0" y="0"/>
+          <a:ext cx="0" cy="0"/>
+          <a:chOff x="0" y="0"/>
+          <a:chExt cx="0" cy="0"/>
+        </a:xfrm>
+      </p:grpSpPr>
       <p:sp>
         <p:nvSpPr>
           <p:cNvPr id="2" name="Rectangle 1"/>
@@ -5265,6 +5269,7 @@
           <a:lstStyle/>
           <a:p>
             <a:pPr algn="ctr"/>
+            <a:endParaRPr/>
           </a:p>
         </p:txBody>
       </p:sp>
@@ -5309,6 +5314,7 @@
           <a:lstStyle/>
           <a:p>
             <a:pPr algn="ctr"/>
+            <a:endParaRPr/>
           </a:p>
         </p:txBody>
       </p:sp>
@@ -5353,6 +5359,7 @@
           <a:lstStyle/>
           <a:p>
             <a:pPr algn="ctr"/>
+            <a:endParaRPr/>
           </a:p>
         </p:txBody>
       </p:sp>
@@ -5404,7 +5411,7 @@
         <p:spPr>
           <a:xfrm>
             <a:off x="731520" y="2377440"/>
-            <a:ext cx="10698480" cy="1554480"/>
+            <a:ext cx="10698480" cy="615553"/>
           </a:xfrm>
           <a:prstGeom prst="rect">
             <a:avLst/>
@@ -5423,14 +5430,29 @@
               </a:spcAft>
             </a:pPr>
             <a:r>
-              <a:rPr sz="3400" b="1">
+              <a:rPr sz="3400" b="1" dirty="0">
                 <a:solidFill>
                   <a:srgbClr val="C0392B"/>
                 </a:solidFill>
                 <a:latin typeface="맑은 고딕"/>
               </a:rPr>
-              <a:t>ASM 인스턴스와</a:t>
-            </a:r>
+              <a:t>ASM </a:t>
+            </a:r>
+            <a:r>
+              <a:rPr sz="3400" b="1" dirty="0" err="1">
+                <a:solidFill>
+                  <a:srgbClr val="C0392B"/>
+                </a:solidFill>
+                <a:latin typeface="맑은 고딕"/>
+              </a:rPr>
+              <a:t>인스턴스</a:t>
+            </a:r>
+            <a:endParaRPr sz="3400" b="1" dirty="0">
+              <a:solidFill>
+                <a:srgbClr val="C0392B"/>
+              </a:solidFill>
+              <a:latin typeface="맑은 고딕"/>
+            </a:endParaRPr>
           </a:p>
         </p:txBody>
       </p:sp>
@@ -5521,7 +5543,7 @@
 </file>
 
 <file path=ppt/slides/slide10.xml><?xml version="1.0" encoding="utf-8"?>
-<p:sld xmlns:a="http://schemas.openxmlformats.org/drawingml/2006/main" xmlns:p="http://schemas.openxmlformats.org/presentationml/2006/main" xmlns:r="http://schemas.openxmlformats.org/officeDocument/2006/relationships">
+<p:sld xmlns:a="http://schemas.openxmlformats.org/drawingml/2006/main" xmlns:r="http://schemas.openxmlformats.org/officeDocument/2006/relationships" xmlns:p="http://schemas.openxmlformats.org/presentationml/2006/main">
   <p:cSld>
     <p:spTree>
       <p:nvGrpSpPr>
@@ -5529,7 +5551,14 @@
         <p:cNvGrpSpPr/>
         <p:nvPr/>
       </p:nvGrpSpPr>
-      <p:grpSpPr/>
+      <p:grpSpPr>
+        <a:xfrm>
+          <a:off x="0" y="0"/>
+          <a:ext cx="0" cy="0"/>
+          <a:chOff x="0" y="0"/>
+          <a:chExt cx="0" cy="0"/>
+        </a:xfrm>
+      </p:grpSpPr>
       <p:sp>
         <p:nvSpPr>
           <p:cNvPr id="2" name="Rectangle 1"/>
@@ -5571,6 +5600,7 @@
           <a:lstStyle/>
           <a:p>
             <a:pPr algn="ctr"/>
+            <a:endParaRPr/>
           </a:p>
         </p:txBody>
       </p:sp>
@@ -5764,7 +5794,7 @@
 </file>
 
 <file path=ppt/slides/slide11.xml><?xml version="1.0" encoding="utf-8"?>
-<p:sld xmlns:a="http://schemas.openxmlformats.org/drawingml/2006/main" xmlns:p="http://schemas.openxmlformats.org/presentationml/2006/main" xmlns:r="http://schemas.openxmlformats.org/officeDocument/2006/relationships">
+<p:sld xmlns:a="http://schemas.openxmlformats.org/drawingml/2006/main" xmlns:r="http://schemas.openxmlformats.org/officeDocument/2006/relationships" xmlns:p="http://schemas.openxmlformats.org/presentationml/2006/main">
   <p:cSld>
     <p:spTree>
       <p:nvGrpSpPr>
@@ -5772,7 +5802,14 @@
         <p:cNvGrpSpPr/>
         <p:nvPr/>
       </p:nvGrpSpPr>
-      <p:grpSpPr/>
+      <p:grpSpPr>
+        <a:xfrm>
+          <a:off x="0" y="0"/>
+          <a:ext cx="0" cy="0"/>
+          <a:chOff x="0" y="0"/>
+          <a:chExt cx="0" cy="0"/>
+        </a:xfrm>
+      </p:grpSpPr>
       <p:sp>
         <p:nvSpPr>
           <p:cNvPr id="2" name="Rectangle 1"/>
@@ -5814,6 +5851,7 @@
           <a:lstStyle/>
           <a:p>
             <a:pPr algn="ctr"/>
+            <a:endParaRPr/>
           </a:p>
         </p:txBody>
       </p:sp>
@@ -5936,6 +5974,7 @@
           <a:lstStyle/>
           <a:p>
             <a:pPr algn="ctr"/>
+            <a:endParaRPr/>
           </a:p>
         </p:txBody>
       </p:sp>
@@ -6019,7 +6058,7 @@
 </file>
 
 <file path=ppt/slides/slide12.xml><?xml version="1.0" encoding="utf-8"?>
-<p:sld xmlns:a="http://schemas.openxmlformats.org/drawingml/2006/main" xmlns:p="http://schemas.openxmlformats.org/presentationml/2006/main" xmlns:r="http://schemas.openxmlformats.org/officeDocument/2006/relationships">
+<p:sld xmlns:a="http://schemas.openxmlformats.org/drawingml/2006/main" xmlns:r="http://schemas.openxmlformats.org/officeDocument/2006/relationships" xmlns:p="http://schemas.openxmlformats.org/presentationml/2006/main">
   <p:cSld>
     <p:spTree>
       <p:nvGrpSpPr>
@@ -6027,7 +6066,14 @@
         <p:cNvGrpSpPr/>
         <p:nvPr/>
       </p:nvGrpSpPr>
-      <p:grpSpPr/>
+      <p:grpSpPr>
+        <a:xfrm>
+          <a:off x="0" y="0"/>
+          <a:ext cx="0" cy="0"/>
+          <a:chOff x="0" y="0"/>
+          <a:chExt cx="0" cy="0"/>
+        </a:xfrm>
+      </p:grpSpPr>
       <p:sp>
         <p:nvSpPr>
           <p:cNvPr id="2" name="Rectangle 1"/>
@@ -6069,6 +6115,7 @@
           <a:lstStyle/>
           <a:p>
             <a:pPr algn="ctr"/>
+            <a:endParaRPr/>
           </a:p>
         </p:txBody>
       </p:sp>
@@ -6262,7 +6309,7 @@
 </file>
 
 <file path=ppt/slides/slide13.xml><?xml version="1.0" encoding="utf-8"?>
-<p:sld xmlns:a="http://schemas.openxmlformats.org/drawingml/2006/main" xmlns:p="http://schemas.openxmlformats.org/presentationml/2006/main" xmlns:r="http://schemas.openxmlformats.org/officeDocument/2006/relationships">
+<p:sld xmlns:a="http://schemas.openxmlformats.org/drawingml/2006/main" xmlns:r="http://schemas.openxmlformats.org/officeDocument/2006/relationships" xmlns:p="http://schemas.openxmlformats.org/presentationml/2006/main">
   <p:cSld>
     <p:spTree>
       <p:nvGrpSpPr>
@@ -6270,7 +6317,14 @@
         <p:cNvGrpSpPr/>
         <p:nvPr/>
       </p:nvGrpSpPr>
-      <p:grpSpPr/>
+      <p:grpSpPr>
+        <a:xfrm>
+          <a:off x="0" y="0"/>
+          <a:ext cx="0" cy="0"/>
+          <a:chOff x="0" y="0"/>
+          <a:chExt cx="0" cy="0"/>
+        </a:xfrm>
+      </p:grpSpPr>
       <p:sp>
         <p:nvSpPr>
           <p:cNvPr id="2" name="Rectangle 1"/>
@@ -6312,6 +6366,7 @@
           <a:lstStyle/>
           <a:p>
             <a:pPr algn="ctr"/>
+            <a:endParaRPr/>
           </a:p>
         </p:txBody>
       </p:sp>
@@ -6505,7 +6560,7 @@
 </file>
 
 <file path=ppt/slides/slide14.xml><?xml version="1.0" encoding="utf-8"?>
-<p:sld xmlns:a="http://schemas.openxmlformats.org/drawingml/2006/main" xmlns:p="http://schemas.openxmlformats.org/presentationml/2006/main" xmlns:r="http://schemas.openxmlformats.org/officeDocument/2006/relationships">
+<p:sld xmlns:a="http://schemas.openxmlformats.org/drawingml/2006/main" xmlns:r="http://schemas.openxmlformats.org/officeDocument/2006/relationships" xmlns:p="http://schemas.openxmlformats.org/presentationml/2006/main">
   <p:cSld>
     <p:spTree>
       <p:nvGrpSpPr>
@@ -6513,7 +6568,14 @@
         <p:cNvGrpSpPr/>
         <p:nvPr/>
       </p:nvGrpSpPr>
-      <p:grpSpPr/>
+      <p:grpSpPr>
+        <a:xfrm>
+          <a:off x="0" y="0"/>
+          <a:ext cx="0" cy="0"/>
+          <a:chOff x="0" y="0"/>
+          <a:chExt cx="0" cy="0"/>
+        </a:xfrm>
+      </p:grpSpPr>
       <p:sp>
         <p:nvSpPr>
           <p:cNvPr id="2" name="Rectangle 1"/>
@@ -6555,6 +6617,7 @@
           <a:lstStyle/>
           <a:p>
             <a:pPr algn="ctr"/>
+            <a:endParaRPr/>
           </a:p>
         </p:txBody>
       </p:sp>
@@ -6748,7 +6811,7 @@
 </file>
 
 <file path=ppt/slides/slide15.xml><?xml version="1.0" encoding="utf-8"?>
-<p:sld xmlns:a="http://schemas.openxmlformats.org/drawingml/2006/main" xmlns:p="http://schemas.openxmlformats.org/presentationml/2006/main" xmlns:r="http://schemas.openxmlformats.org/officeDocument/2006/relationships">
+<p:sld xmlns:a="http://schemas.openxmlformats.org/drawingml/2006/main" xmlns:r="http://schemas.openxmlformats.org/officeDocument/2006/relationships" xmlns:p="http://schemas.openxmlformats.org/presentationml/2006/main">
   <p:cSld>
     <p:spTree>
       <p:nvGrpSpPr>
@@ -6756,7 +6819,14 @@
         <p:cNvGrpSpPr/>
         <p:nvPr/>
       </p:nvGrpSpPr>
-      <p:grpSpPr/>
+      <p:grpSpPr>
+        <a:xfrm>
+          <a:off x="0" y="0"/>
+          <a:ext cx="0" cy="0"/>
+          <a:chOff x="0" y="0"/>
+          <a:chExt cx="0" cy="0"/>
+        </a:xfrm>
+      </p:grpSpPr>
       <p:sp>
         <p:nvSpPr>
           <p:cNvPr id="2" name="Rectangle 1"/>
@@ -6798,6 +6868,7 @@
           <a:lstStyle/>
           <a:p>
             <a:pPr algn="ctr"/>
+            <a:endParaRPr/>
           </a:p>
         </p:txBody>
       </p:sp>
@@ -6991,7 +7062,7 @@
 </file>
 
 <file path=ppt/slides/slide16.xml><?xml version="1.0" encoding="utf-8"?>
-<p:sld xmlns:a="http://schemas.openxmlformats.org/drawingml/2006/main" xmlns:p="http://schemas.openxmlformats.org/presentationml/2006/main" xmlns:r="http://schemas.openxmlformats.org/officeDocument/2006/relationships">
+<p:sld xmlns:a="http://schemas.openxmlformats.org/drawingml/2006/main" xmlns:r="http://schemas.openxmlformats.org/officeDocument/2006/relationships" xmlns:p="http://schemas.openxmlformats.org/presentationml/2006/main">
   <p:cSld>
     <p:spTree>
       <p:nvGrpSpPr>
@@ -6999,7 +7070,14 @@
         <p:cNvGrpSpPr/>
         <p:nvPr/>
       </p:nvGrpSpPr>
-      <p:grpSpPr/>
+      <p:grpSpPr>
+        <a:xfrm>
+          <a:off x="0" y="0"/>
+          <a:ext cx="0" cy="0"/>
+          <a:chOff x="0" y="0"/>
+          <a:chExt cx="0" cy="0"/>
+        </a:xfrm>
+      </p:grpSpPr>
       <p:sp>
         <p:nvSpPr>
           <p:cNvPr id="2" name="Rectangle 1"/>
@@ -7041,6 +7119,7 @@
           <a:lstStyle/>
           <a:p>
             <a:pPr algn="ctr"/>
+            <a:endParaRPr/>
           </a:p>
         </p:txBody>
       </p:sp>
@@ -7163,6 +7242,7 @@
           <a:lstStyle/>
           <a:p>
             <a:pPr algn="ctr"/>
+            <a:endParaRPr/>
           </a:p>
         </p:txBody>
       </p:sp>
@@ -7262,7 +7342,7 @@
 </file>
 
 <file path=ppt/slides/slide17.xml><?xml version="1.0" encoding="utf-8"?>
-<p:sld xmlns:a="http://schemas.openxmlformats.org/drawingml/2006/main" xmlns:p="http://schemas.openxmlformats.org/presentationml/2006/main" xmlns:r="http://schemas.openxmlformats.org/officeDocument/2006/relationships">
+<p:sld xmlns:a="http://schemas.openxmlformats.org/drawingml/2006/main" xmlns:r="http://schemas.openxmlformats.org/officeDocument/2006/relationships" xmlns:p="http://schemas.openxmlformats.org/presentationml/2006/main">
   <p:cSld>
     <p:spTree>
       <p:nvGrpSpPr>
@@ -7270,7 +7350,14 @@
         <p:cNvGrpSpPr/>
         <p:nvPr/>
       </p:nvGrpSpPr>
-      <p:grpSpPr/>
+      <p:grpSpPr>
+        <a:xfrm>
+          <a:off x="0" y="0"/>
+          <a:ext cx="0" cy="0"/>
+          <a:chOff x="0" y="0"/>
+          <a:chExt cx="0" cy="0"/>
+        </a:xfrm>
+      </p:grpSpPr>
       <p:sp>
         <p:nvSpPr>
           <p:cNvPr id="2" name="Rectangle 1"/>
@@ -7312,6 +7399,7 @@
           <a:lstStyle/>
           <a:p>
             <a:pPr algn="ctr"/>
+            <a:endParaRPr/>
           </a:p>
         </p:txBody>
       </p:sp>
@@ -7505,7 +7593,7 @@
 </file>
 
 <file path=ppt/slides/slide18.xml><?xml version="1.0" encoding="utf-8"?>
-<p:sld xmlns:a="http://schemas.openxmlformats.org/drawingml/2006/main" xmlns:p="http://schemas.openxmlformats.org/presentationml/2006/main" xmlns:r="http://schemas.openxmlformats.org/officeDocument/2006/relationships">
+<p:sld xmlns:a="http://schemas.openxmlformats.org/drawingml/2006/main" xmlns:r="http://schemas.openxmlformats.org/officeDocument/2006/relationships" xmlns:p="http://schemas.openxmlformats.org/presentationml/2006/main">
   <p:cSld>
     <p:spTree>
       <p:nvGrpSpPr>
@@ -7513,7 +7601,14 @@
         <p:cNvGrpSpPr/>
         <p:nvPr/>
       </p:nvGrpSpPr>
-      <p:grpSpPr/>
+      <p:grpSpPr>
+        <a:xfrm>
+          <a:off x="0" y="0"/>
+          <a:ext cx="0" cy="0"/>
+          <a:chOff x="0" y="0"/>
+          <a:chExt cx="0" cy="0"/>
+        </a:xfrm>
+      </p:grpSpPr>
       <p:sp>
         <p:nvSpPr>
           <p:cNvPr id="2" name="Rectangle 1"/>
@@ -7555,6 +7650,7 @@
           <a:lstStyle/>
           <a:p>
             <a:pPr algn="ctr"/>
+            <a:endParaRPr/>
           </a:p>
         </p:txBody>
       </p:sp>
@@ -7748,7 +7844,7 @@
 </file>
 
 <file path=ppt/slides/slide19.xml><?xml version="1.0" encoding="utf-8"?>
-<p:sld xmlns:a="http://schemas.openxmlformats.org/drawingml/2006/main" xmlns:p="http://schemas.openxmlformats.org/presentationml/2006/main" xmlns:r="http://schemas.openxmlformats.org/officeDocument/2006/relationships">
+<p:sld xmlns:a="http://schemas.openxmlformats.org/drawingml/2006/main" xmlns:r="http://schemas.openxmlformats.org/officeDocument/2006/relationships" xmlns:p="http://schemas.openxmlformats.org/presentationml/2006/main">
   <p:cSld>
     <p:spTree>
       <p:nvGrpSpPr>
@@ -7756,7 +7852,14 @@
         <p:cNvGrpSpPr/>
         <p:nvPr/>
       </p:nvGrpSpPr>
-      <p:grpSpPr/>
+      <p:grpSpPr>
+        <a:xfrm>
+          <a:off x="0" y="0"/>
+          <a:ext cx="0" cy="0"/>
+          <a:chOff x="0" y="0"/>
+          <a:chExt cx="0" cy="0"/>
+        </a:xfrm>
+      </p:grpSpPr>
       <p:sp>
         <p:nvSpPr>
           <p:cNvPr id="2" name="Rectangle 1"/>
@@ -7798,6 +7901,7 @@
           <a:lstStyle/>
           <a:p>
             <a:pPr algn="ctr"/>
+            <a:endParaRPr/>
           </a:p>
         </p:txBody>
       </p:sp>
@@ -7991,7 +8095,7 @@
 </file>
 
 <file path=ppt/slides/slide2.xml><?xml version="1.0" encoding="utf-8"?>
-<p:sld xmlns:a="http://schemas.openxmlformats.org/drawingml/2006/main" xmlns:p="http://schemas.openxmlformats.org/presentationml/2006/main" xmlns:r="http://schemas.openxmlformats.org/officeDocument/2006/relationships">
+<p:sld xmlns:a="http://schemas.openxmlformats.org/drawingml/2006/main" xmlns:r="http://schemas.openxmlformats.org/officeDocument/2006/relationships" xmlns:p="http://schemas.openxmlformats.org/presentationml/2006/main">
   <p:cSld>
     <p:spTree>
       <p:nvGrpSpPr>
@@ -7999,7 +8103,14 @@
         <p:cNvGrpSpPr/>
         <p:nvPr/>
       </p:nvGrpSpPr>
-      <p:grpSpPr/>
+      <p:grpSpPr>
+        <a:xfrm>
+          <a:off x="0" y="0"/>
+          <a:ext cx="0" cy="0"/>
+          <a:chOff x="0" y="0"/>
+          <a:chExt cx="0" cy="0"/>
+        </a:xfrm>
+      </p:grpSpPr>
       <p:sp>
         <p:nvSpPr>
           <p:cNvPr id="2" name="Rectangle 1"/>
@@ -8041,6 +8152,7 @@
           <a:lstStyle/>
           <a:p>
             <a:pPr algn="ctr"/>
+            <a:endParaRPr/>
           </a:p>
         </p:txBody>
       </p:sp>
@@ -8227,7 +8339,7 @@
 </file>
 
 <file path=ppt/slides/slide20.xml><?xml version="1.0" encoding="utf-8"?>
-<p:sld xmlns:a="http://schemas.openxmlformats.org/drawingml/2006/main" xmlns:p="http://schemas.openxmlformats.org/presentationml/2006/main" xmlns:r="http://schemas.openxmlformats.org/officeDocument/2006/relationships">
+<p:sld xmlns:a="http://schemas.openxmlformats.org/drawingml/2006/main" xmlns:r="http://schemas.openxmlformats.org/officeDocument/2006/relationships" xmlns:p="http://schemas.openxmlformats.org/presentationml/2006/main">
   <p:cSld>
     <p:spTree>
       <p:nvGrpSpPr>
@@ -8235,7 +8347,14 @@
         <p:cNvGrpSpPr/>
         <p:nvPr/>
       </p:nvGrpSpPr>
-      <p:grpSpPr/>
+      <p:grpSpPr>
+        <a:xfrm>
+          <a:off x="0" y="0"/>
+          <a:ext cx="0" cy="0"/>
+          <a:chOff x="0" y="0"/>
+          <a:chExt cx="0" cy="0"/>
+        </a:xfrm>
+      </p:grpSpPr>
       <p:sp>
         <p:nvSpPr>
           <p:cNvPr id="2" name="Rectangle 1"/>
@@ -8277,6 +8396,7 @@
           <a:lstStyle/>
           <a:p>
             <a:pPr algn="ctr"/>
+            <a:endParaRPr/>
           </a:p>
         </p:txBody>
       </p:sp>
@@ -8470,7 +8590,7 @@
 </file>
 
 <file path=ppt/slides/slide21.xml><?xml version="1.0" encoding="utf-8"?>
-<p:sld xmlns:a="http://schemas.openxmlformats.org/drawingml/2006/main" xmlns:p="http://schemas.openxmlformats.org/presentationml/2006/main" xmlns:r="http://schemas.openxmlformats.org/officeDocument/2006/relationships">
+<p:sld xmlns:a="http://schemas.openxmlformats.org/drawingml/2006/main" xmlns:r="http://schemas.openxmlformats.org/officeDocument/2006/relationships" xmlns:p="http://schemas.openxmlformats.org/presentationml/2006/main">
   <p:cSld>
     <p:spTree>
       <p:nvGrpSpPr>
@@ -8478,7 +8598,14 @@
         <p:cNvGrpSpPr/>
         <p:nvPr/>
       </p:nvGrpSpPr>
-      <p:grpSpPr/>
+      <p:grpSpPr>
+        <a:xfrm>
+          <a:off x="0" y="0"/>
+          <a:ext cx="0" cy="0"/>
+          <a:chOff x="0" y="0"/>
+          <a:chExt cx="0" cy="0"/>
+        </a:xfrm>
+      </p:grpSpPr>
       <p:sp>
         <p:nvSpPr>
           <p:cNvPr id="2" name="Rectangle 1"/>
@@ -8520,6 +8647,7 @@
           <a:lstStyle/>
           <a:p>
             <a:pPr algn="ctr"/>
+            <a:endParaRPr/>
           </a:p>
         </p:txBody>
       </p:sp>
@@ -8713,7 +8841,7 @@
 </file>
 
 <file path=ppt/slides/slide22.xml><?xml version="1.0" encoding="utf-8"?>
-<p:sld xmlns:a="http://schemas.openxmlformats.org/drawingml/2006/main" xmlns:p="http://schemas.openxmlformats.org/presentationml/2006/main" xmlns:r="http://schemas.openxmlformats.org/officeDocument/2006/relationships">
+<p:sld xmlns:a="http://schemas.openxmlformats.org/drawingml/2006/main" xmlns:r="http://schemas.openxmlformats.org/officeDocument/2006/relationships" xmlns:p="http://schemas.openxmlformats.org/presentationml/2006/main">
   <p:cSld>
     <p:spTree>
       <p:nvGrpSpPr>
@@ -8721,7 +8849,14 @@
         <p:cNvGrpSpPr/>
         <p:nvPr/>
       </p:nvGrpSpPr>
-      <p:grpSpPr/>
+      <p:grpSpPr>
+        <a:xfrm>
+          <a:off x="0" y="0"/>
+          <a:ext cx="0" cy="0"/>
+          <a:chOff x="0" y="0"/>
+          <a:chExt cx="0" cy="0"/>
+        </a:xfrm>
+      </p:grpSpPr>
       <p:sp>
         <p:nvSpPr>
           <p:cNvPr id="2" name="Rectangle 1"/>
@@ -8763,6 +8898,7 @@
           <a:lstStyle/>
           <a:p>
             <a:pPr algn="ctr"/>
+            <a:endParaRPr/>
           </a:p>
         </p:txBody>
       </p:sp>
@@ -8885,6 +9021,7 @@
           <a:lstStyle/>
           <a:p>
             <a:pPr algn="ctr"/>
+            <a:endParaRPr/>
           </a:p>
         </p:txBody>
       </p:sp>
@@ -8968,7 +9105,7 @@
 </file>
 
 <file path=ppt/slides/slide23.xml><?xml version="1.0" encoding="utf-8"?>
-<p:sld xmlns:a="http://schemas.openxmlformats.org/drawingml/2006/main" xmlns:p="http://schemas.openxmlformats.org/presentationml/2006/main" xmlns:r="http://schemas.openxmlformats.org/officeDocument/2006/relationships">
+<p:sld xmlns:a="http://schemas.openxmlformats.org/drawingml/2006/main" xmlns:r="http://schemas.openxmlformats.org/officeDocument/2006/relationships" xmlns:p="http://schemas.openxmlformats.org/presentationml/2006/main">
   <p:cSld>
     <p:spTree>
       <p:nvGrpSpPr>
@@ -8976,7 +9113,14 @@
         <p:cNvGrpSpPr/>
         <p:nvPr/>
       </p:nvGrpSpPr>
-      <p:grpSpPr/>
+      <p:grpSpPr>
+        <a:xfrm>
+          <a:off x="0" y="0"/>
+          <a:ext cx="0" cy="0"/>
+          <a:chOff x="0" y="0"/>
+          <a:chExt cx="0" cy="0"/>
+        </a:xfrm>
+      </p:grpSpPr>
       <p:sp>
         <p:nvSpPr>
           <p:cNvPr id="2" name="Rectangle 1"/>
@@ -9018,6 +9162,7 @@
           <a:lstStyle/>
           <a:p>
             <a:pPr algn="ctr"/>
+            <a:endParaRPr/>
           </a:p>
         </p:txBody>
       </p:sp>
@@ -9211,7 +9356,7 @@
 </file>
 
 <file path=ppt/slides/slide24.xml><?xml version="1.0" encoding="utf-8"?>
-<p:sld xmlns:a="http://schemas.openxmlformats.org/drawingml/2006/main" xmlns:p="http://schemas.openxmlformats.org/presentationml/2006/main" xmlns:r="http://schemas.openxmlformats.org/officeDocument/2006/relationships">
+<p:sld xmlns:a="http://schemas.openxmlformats.org/drawingml/2006/main" xmlns:r="http://schemas.openxmlformats.org/officeDocument/2006/relationships" xmlns:p="http://schemas.openxmlformats.org/presentationml/2006/main">
   <p:cSld>
     <p:spTree>
       <p:nvGrpSpPr>
@@ -9219,7 +9364,14 @@
         <p:cNvGrpSpPr/>
         <p:nvPr/>
       </p:nvGrpSpPr>
-      <p:grpSpPr/>
+      <p:grpSpPr>
+        <a:xfrm>
+          <a:off x="0" y="0"/>
+          <a:ext cx="0" cy="0"/>
+          <a:chOff x="0" y="0"/>
+          <a:chExt cx="0" cy="0"/>
+        </a:xfrm>
+      </p:grpSpPr>
       <p:sp>
         <p:nvSpPr>
           <p:cNvPr id="2" name="Rectangle 1"/>
@@ -9261,6 +9413,7 @@
           <a:lstStyle/>
           <a:p>
             <a:pPr algn="ctr"/>
+            <a:endParaRPr/>
           </a:p>
         </p:txBody>
       </p:sp>
@@ -9454,7 +9607,7 @@
 </file>
 
 <file path=ppt/slides/slide25.xml><?xml version="1.0" encoding="utf-8"?>
-<p:sld xmlns:a="http://schemas.openxmlformats.org/drawingml/2006/main" xmlns:p="http://schemas.openxmlformats.org/presentationml/2006/main" xmlns:r="http://schemas.openxmlformats.org/officeDocument/2006/relationships">
+<p:sld xmlns:a="http://schemas.openxmlformats.org/drawingml/2006/main" xmlns:r="http://schemas.openxmlformats.org/officeDocument/2006/relationships" xmlns:p="http://schemas.openxmlformats.org/presentationml/2006/main">
   <p:cSld>
     <p:spTree>
       <p:nvGrpSpPr>
@@ -9462,7 +9615,14 @@
         <p:cNvGrpSpPr/>
         <p:nvPr/>
       </p:nvGrpSpPr>
-      <p:grpSpPr/>
+      <p:grpSpPr>
+        <a:xfrm>
+          <a:off x="0" y="0"/>
+          <a:ext cx="0" cy="0"/>
+          <a:chOff x="0" y="0"/>
+          <a:chExt cx="0" cy="0"/>
+        </a:xfrm>
+      </p:grpSpPr>
       <p:sp>
         <p:nvSpPr>
           <p:cNvPr id="2" name="Rectangle 1"/>
@@ -9504,6 +9664,7 @@
           <a:lstStyle/>
           <a:p>
             <a:pPr algn="ctr"/>
+            <a:endParaRPr/>
           </a:p>
         </p:txBody>
       </p:sp>
@@ -9697,7 +9858,7 @@
 </file>
 
 <file path=ppt/slides/slide26.xml><?xml version="1.0" encoding="utf-8"?>
-<p:sld xmlns:a="http://schemas.openxmlformats.org/drawingml/2006/main" xmlns:p="http://schemas.openxmlformats.org/presentationml/2006/main" xmlns:r="http://schemas.openxmlformats.org/officeDocument/2006/relationships">
+<p:sld xmlns:a="http://schemas.openxmlformats.org/drawingml/2006/main" xmlns:r="http://schemas.openxmlformats.org/officeDocument/2006/relationships" xmlns:p="http://schemas.openxmlformats.org/presentationml/2006/main">
   <p:cSld>
     <p:spTree>
       <p:nvGrpSpPr>
@@ -9705,7 +9866,14 @@
         <p:cNvGrpSpPr/>
         <p:nvPr/>
       </p:nvGrpSpPr>
-      <p:grpSpPr/>
+      <p:grpSpPr>
+        <a:xfrm>
+          <a:off x="0" y="0"/>
+          <a:ext cx="0" cy="0"/>
+          <a:chOff x="0" y="0"/>
+          <a:chExt cx="0" cy="0"/>
+        </a:xfrm>
+      </p:grpSpPr>
       <p:sp>
         <p:nvSpPr>
           <p:cNvPr id="2" name="Rectangle 1"/>
@@ -9747,6 +9915,7 @@
           <a:lstStyle/>
           <a:p>
             <a:pPr algn="ctr"/>
+            <a:endParaRPr/>
           </a:p>
         </p:txBody>
       </p:sp>
@@ -9869,6 +10038,7 @@
           <a:lstStyle/>
           <a:p>
             <a:pPr algn="ctr"/>
+            <a:endParaRPr/>
           </a:p>
         </p:txBody>
       </p:sp>
@@ -9952,7 +10122,7 @@
 </file>
 
 <file path=ppt/slides/slide27.xml><?xml version="1.0" encoding="utf-8"?>
-<p:sld xmlns:a="http://schemas.openxmlformats.org/drawingml/2006/main" xmlns:p="http://schemas.openxmlformats.org/presentationml/2006/main" xmlns:r="http://schemas.openxmlformats.org/officeDocument/2006/relationships">
+<p:sld xmlns:a="http://schemas.openxmlformats.org/drawingml/2006/main" xmlns:r="http://schemas.openxmlformats.org/officeDocument/2006/relationships" xmlns:p="http://schemas.openxmlformats.org/presentationml/2006/main">
   <p:cSld>
     <p:spTree>
       <p:nvGrpSpPr>
@@ -9960,7 +10130,14 @@
         <p:cNvGrpSpPr/>
         <p:nvPr/>
       </p:nvGrpSpPr>
-      <p:grpSpPr/>
+      <p:grpSpPr>
+        <a:xfrm>
+          <a:off x="0" y="0"/>
+          <a:ext cx="0" cy="0"/>
+          <a:chOff x="0" y="0"/>
+          <a:chExt cx="0" cy="0"/>
+        </a:xfrm>
+      </p:grpSpPr>
       <p:sp>
         <p:nvSpPr>
           <p:cNvPr id="2" name="Rectangle 1"/>
@@ -10002,6 +10179,7 @@
           <a:lstStyle/>
           <a:p>
             <a:pPr algn="ctr"/>
+            <a:endParaRPr/>
           </a:p>
         </p:txBody>
       </p:sp>
@@ -10195,7 +10373,7 @@
 </file>
 
 <file path=ppt/slides/slide28.xml><?xml version="1.0" encoding="utf-8"?>
-<p:sld xmlns:a="http://schemas.openxmlformats.org/drawingml/2006/main" xmlns:p="http://schemas.openxmlformats.org/presentationml/2006/main" xmlns:r="http://schemas.openxmlformats.org/officeDocument/2006/relationships">
+<p:sld xmlns:a="http://schemas.openxmlformats.org/drawingml/2006/main" xmlns:r="http://schemas.openxmlformats.org/officeDocument/2006/relationships" xmlns:p="http://schemas.openxmlformats.org/presentationml/2006/main">
   <p:cSld>
     <p:spTree>
       <p:nvGrpSpPr>
@@ -10203,7 +10381,14 @@
         <p:cNvGrpSpPr/>
         <p:nvPr/>
       </p:nvGrpSpPr>
-      <p:grpSpPr/>
+      <p:grpSpPr>
+        <a:xfrm>
+          <a:off x="0" y="0"/>
+          <a:ext cx="0" cy="0"/>
+          <a:chOff x="0" y="0"/>
+          <a:chExt cx="0" cy="0"/>
+        </a:xfrm>
+      </p:grpSpPr>
       <p:sp>
         <p:nvSpPr>
           <p:cNvPr id="2" name="Rectangle 1"/>
@@ -10245,6 +10430,7 @@
           <a:lstStyle/>
           <a:p>
             <a:pPr algn="ctr"/>
+            <a:endParaRPr/>
           </a:p>
         </p:txBody>
       </p:sp>
@@ -10438,7 +10624,7 @@
 </file>
 
 <file path=ppt/slides/slide29.xml><?xml version="1.0" encoding="utf-8"?>
-<p:sld xmlns:a="http://schemas.openxmlformats.org/drawingml/2006/main" xmlns:p="http://schemas.openxmlformats.org/presentationml/2006/main" xmlns:r="http://schemas.openxmlformats.org/officeDocument/2006/relationships">
+<p:sld xmlns:a="http://schemas.openxmlformats.org/drawingml/2006/main" xmlns:r="http://schemas.openxmlformats.org/officeDocument/2006/relationships" xmlns:p="http://schemas.openxmlformats.org/presentationml/2006/main">
   <p:cSld>
     <p:spTree>
       <p:nvGrpSpPr>
@@ -10446,7 +10632,14 @@
         <p:cNvGrpSpPr/>
         <p:nvPr/>
       </p:nvGrpSpPr>
-      <p:grpSpPr/>
+      <p:grpSpPr>
+        <a:xfrm>
+          <a:off x="0" y="0"/>
+          <a:ext cx="0" cy="0"/>
+          <a:chOff x="0" y="0"/>
+          <a:chExt cx="0" cy="0"/>
+        </a:xfrm>
+      </p:grpSpPr>
       <p:sp>
         <p:nvSpPr>
           <p:cNvPr id="2" name="Rectangle 1"/>
@@ -10488,6 +10681,7 @@
           <a:lstStyle/>
           <a:p>
             <a:pPr algn="ctr"/>
+            <a:endParaRPr/>
           </a:p>
         </p:txBody>
       </p:sp>
@@ -10681,7 +10875,7 @@
 </file>
 
 <file path=ppt/slides/slide3.xml><?xml version="1.0" encoding="utf-8"?>
-<p:sld xmlns:a="http://schemas.openxmlformats.org/drawingml/2006/main" xmlns:p="http://schemas.openxmlformats.org/presentationml/2006/main" xmlns:r="http://schemas.openxmlformats.org/officeDocument/2006/relationships">
+<p:sld xmlns:a="http://schemas.openxmlformats.org/drawingml/2006/main" xmlns:r="http://schemas.openxmlformats.org/officeDocument/2006/relationships" xmlns:p="http://schemas.openxmlformats.org/presentationml/2006/main">
   <p:cSld>
     <p:spTree>
       <p:nvGrpSpPr>
@@ -10689,7 +10883,14 @@
         <p:cNvGrpSpPr/>
         <p:nvPr/>
       </p:nvGrpSpPr>
-      <p:grpSpPr/>
+      <p:grpSpPr>
+        <a:xfrm>
+          <a:off x="0" y="0"/>
+          <a:ext cx="0" cy="0"/>
+          <a:chOff x="0" y="0"/>
+          <a:chExt cx="0" cy="0"/>
+        </a:xfrm>
+      </p:grpSpPr>
       <p:sp>
         <p:nvSpPr>
           <p:cNvPr id="2" name="Rectangle 1"/>
@@ -10731,6 +10932,7 @@
           <a:lstStyle/>
           <a:p>
             <a:pPr algn="ctr"/>
+            <a:endParaRPr/>
           </a:p>
         </p:txBody>
       </p:sp>
@@ -10885,7 +11087,7 @@
 </file>
 
 <file path=ppt/slides/slide30.xml><?xml version="1.0" encoding="utf-8"?>
-<p:sld xmlns:a="http://schemas.openxmlformats.org/drawingml/2006/main" xmlns:p="http://schemas.openxmlformats.org/presentationml/2006/main" xmlns:r="http://schemas.openxmlformats.org/officeDocument/2006/relationships">
+<p:sld xmlns:a="http://schemas.openxmlformats.org/drawingml/2006/main" xmlns:r="http://schemas.openxmlformats.org/officeDocument/2006/relationships" xmlns:p="http://schemas.openxmlformats.org/presentationml/2006/main">
   <p:cSld>
     <p:spTree>
       <p:nvGrpSpPr>
@@ -10893,7 +11095,14 @@
         <p:cNvGrpSpPr/>
         <p:nvPr/>
       </p:nvGrpSpPr>
-      <p:grpSpPr/>
+      <p:grpSpPr>
+        <a:xfrm>
+          <a:off x="0" y="0"/>
+          <a:ext cx="0" cy="0"/>
+          <a:chOff x="0" y="0"/>
+          <a:chExt cx="0" cy="0"/>
+        </a:xfrm>
+      </p:grpSpPr>
       <p:sp>
         <p:nvSpPr>
           <p:cNvPr id="2" name="Rectangle 1"/>
@@ -10935,6 +11144,7 @@
           <a:lstStyle/>
           <a:p>
             <a:pPr algn="ctr"/>
+            <a:endParaRPr/>
           </a:p>
         </p:txBody>
       </p:sp>
@@ -11057,6 +11267,7 @@
           <a:lstStyle/>
           <a:p>
             <a:pPr algn="ctr"/>
+            <a:endParaRPr/>
           </a:p>
         </p:txBody>
       </p:sp>
@@ -11140,7 +11351,7 @@
 </file>
 
 <file path=ppt/slides/slide31.xml><?xml version="1.0" encoding="utf-8"?>
-<p:sld xmlns:a="http://schemas.openxmlformats.org/drawingml/2006/main" xmlns:p="http://schemas.openxmlformats.org/presentationml/2006/main" xmlns:r="http://schemas.openxmlformats.org/officeDocument/2006/relationships">
+<p:sld xmlns:a="http://schemas.openxmlformats.org/drawingml/2006/main" xmlns:r="http://schemas.openxmlformats.org/officeDocument/2006/relationships" xmlns:p="http://schemas.openxmlformats.org/presentationml/2006/main">
   <p:cSld>
     <p:spTree>
       <p:nvGrpSpPr>
@@ -11148,7 +11359,14 @@
         <p:cNvGrpSpPr/>
         <p:nvPr/>
       </p:nvGrpSpPr>
-      <p:grpSpPr/>
+      <p:grpSpPr>
+        <a:xfrm>
+          <a:off x="0" y="0"/>
+          <a:ext cx="0" cy="0"/>
+          <a:chOff x="0" y="0"/>
+          <a:chExt cx="0" cy="0"/>
+        </a:xfrm>
+      </p:grpSpPr>
       <p:sp>
         <p:nvSpPr>
           <p:cNvPr id="2" name="Rectangle 1"/>
@@ -11190,6 +11408,7 @@
           <a:lstStyle/>
           <a:p>
             <a:pPr algn="ctr"/>
+            <a:endParaRPr/>
           </a:p>
         </p:txBody>
       </p:sp>
@@ -11383,7 +11602,7 @@
 </file>
 
 <file path=ppt/slides/slide32.xml><?xml version="1.0" encoding="utf-8"?>
-<p:sld xmlns:a="http://schemas.openxmlformats.org/drawingml/2006/main" xmlns:p="http://schemas.openxmlformats.org/presentationml/2006/main" xmlns:r="http://schemas.openxmlformats.org/officeDocument/2006/relationships">
+<p:sld xmlns:a="http://schemas.openxmlformats.org/drawingml/2006/main" xmlns:r="http://schemas.openxmlformats.org/officeDocument/2006/relationships" xmlns:p="http://schemas.openxmlformats.org/presentationml/2006/main">
   <p:cSld>
     <p:spTree>
       <p:nvGrpSpPr>
@@ -11391,7 +11610,14 @@
         <p:cNvGrpSpPr/>
         <p:nvPr/>
       </p:nvGrpSpPr>
-      <p:grpSpPr/>
+      <p:grpSpPr>
+        <a:xfrm>
+          <a:off x="0" y="0"/>
+          <a:ext cx="0" cy="0"/>
+          <a:chOff x="0" y="0"/>
+          <a:chExt cx="0" cy="0"/>
+        </a:xfrm>
+      </p:grpSpPr>
       <p:sp>
         <p:nvSpPr>
           <p:cNvPr id="2" name="Rectangle 1"/>
@@ -11433,6 +11659,7 @@
           <a:lstStyle/>
           <a:p>
             <a:pPr algn="ctr"/>
+            <a:endParaRPr/>
           </a:p>
         </p:txBody>
       </p:sp>
@@ -11626,7 +11853,7 @@
 </file>
 
 <file path=ppt/slides/slide33.xml><?xml version="1.0" encoding="utf-8"?>
-<p:sld xmlns:a="http://schemas.openxmlformats.org/drawingml/2006/main" xmlns:p="http://schemas.openxmlformats.org/presentationml/2006/main" xmlns:r="http://schemas.openxmlformats.org/officeDocument/2006/relationships">
+<p:sld xmlns:a="http://schemas.openxmlformats.org/drawingml/2006/main" xmlns:r="http://schemas.openxmlformats.org/officeDocument/2006/relationships" xmlns:p="http://schemas.openxmlformats.org/presentationml/2006/main">
   <p:cSld>
     <p:spTree>
       <p:nvGrpSpPr>
@@ -11634,7 +11861,14 @@
         <p:cNvGrpSpPr/>
         <p:nvPr/>
       </p:nvGrpSpPr>
-      <p:grpSpPr/>
+      <p:grpSpPr>
+        <a:xfrm>
+          <a:off x="0" y="0"/>
+          <a:ext cx="0" cy="0"/>
+          <a:chOff x="0" y="0"/>
+          <a:chExt cx="0" cy="0"/>
+        </a:xfrm>
+      </p:grpSpPr>
       <p:sp>
         <p:nvSpPr>
           <p:cNvPr id="2" name="Rectangle 1"/>
@@ -11676,6 +11910,7 @@
           <a:lstStyle/>
           <a:p>
             <a:pPr algn="ctr"/>
+            <a:endParaRPr/>
           </a:p>
         </p:txBody>
       </p:sp>
@@ -11869,7 +12104,7 @@
 </file>
 
 <file path=ppt/slides/slide34.xml><?xml version="1.0" encoding="utf-8"?>
-<p:sld xmlns:a="http://schemas.openxmlformats.org/drawingml/2006/main" xmlns:p="http://schemas.openxmlformats.org/presentationml/2006/main" xmlns:r="http://schemas.openxmlformats.org/officeDocument/2006/relationships">
+<p:sld xmlns:a="http://schemas.openxmlformats.org/drawingml/2006/main" xmlns:r="http://schemas.openxmlformats.org/officeDocument/2006/relationships" xmlns:p="http://schemas.openxmlformats.org/presentationml/2006/main">
   <p:cSld>
     <p:spTree>
       <p:nvGrpSpPr>
@@ -11877,7 +12112,14 @@
         <p:cNvGrpSpPr/>
         <p:nvPr/>
       </p:nvGrpSpPr>
-      <p:grpSpPr/>
+      <p:grpSpPr>
+        <a:xfrm>
+          <a:off x="0" y="0"/>
+          <a:ext cx="0" cy="0"/>
+          <a:chOff x="0" y="0"/>
+          <a:chExt cx="0" cy="0"/>
+        </a:xfrm>
+      </p:grpSpPr>
       <p:sp>
         <p:nvSpPr>
           <p:cNvPr id="2" name="Rectangle 1"/>
@@ -11919,6 +12161,7 @@
           <a:lstStyle/>
           <a:p>
             <a:pPr algn="ctr"/>
+            <a:endParaRPr/>
           </a:p>
         </p:txBody>
       </p:sp>
@@ -12112,7 +12355,7 @@
 </file>
 
 <file path=ppt/slides/slide35.xml><?xml version="1.0" encoding="utf-8"?>
-<p:sld xmlns:a="http://schemas.openxmlformats.org/drawingml/2006/main" xmlns:p="http://schemas.openxmlformats.org/presentationml/2006/main" xmlns:r="http://schemas.openxmlformats.org/officeDocument/2006/relationships">
+<p:sld xmlns:a="http://schemas.openxmlformats.org/drawingml/2006/main" xmlns:r="http://schemas.openxmlformats.org/officeDocument/2006/relationships" xmlns:p="http://schemas.openxmlformats.org/presentationml/2006/main">
   <p:cSld>
     <p:spTree>
       <p:nvGrpSpPr>
@@ -12120,7 +12363,14 @@
         <p:cNvGrpSpPr/>
         <p:nvPr/>
       </p:nvGrpSpPr>
-      <p:grpSpPr/>
+      <p:grpSpPr>
+        <a:xfrm>
+          <a:off x="0" y="0"/>
+          <a:ext cx="0" cy="0"/>
+          <a:chOff x="0" y="0"/>
+          <a:chExt cx="0" cy="0"/>
+        </a:xfrm>
+      </p:grpSpPr>
       <p:sp>
         <p:nvSpPr>
           <p:cNvPr id="2" name="Rectangle 1"/>
@@ -12162,6 +12412,7 @@
           <a:lstStyle/>
           <a:p>
             <a:pPr algn="ctr"/>
+            <a:endParaRPr/>
           </a:p>
         </p:txBody>
       </p:sp>
@@ -12396,7 +12647,7 @@
 </file>
 
 <file path=ppt/slides/slide36.xml><?xml version="1.0" encoding="utf-8"?>
-<p:sld xmlns:a="http://schemas.openxmlformats.org/drawingml/2006/main" xmlns:p="http://schemas.openxmlformats.org/presentationml/2006/main" xmlns:r="http://schemas.openxmlformats.org/officeDocument/2006/relationships">
+<p:sld xmlns:a="http://schemas.openxmlformats.org/drawingml/2006/main" xmlns:r="http://schemas.openxmlformats.org/officeDocument/2006/relationships" xmlns:p="http://schemas.openxmlformats.org/presentationml/2006/main">
   <p:cSld>
     <p:spTree>
       <p:nvGrpSpPr>
@@ -12404,7 +12655,14 @@
         <p:cNvGrpSpPr/>
         <p:nvPr/>
       </p:nvGrpSpPr>
-      <p:grpSpPr/>
+      <p:grpSpPr>
+        <a:xfrm>
+          <a:off x="0" y="0"/>
+          <a:ext cx="0" cy="0"/>
+          <a:chOff x="0" y="0"/>
+          <a:chExt cx="0" cy="0"/>
+        </a:xfrm>
+      </p:grpSpPr>
       <p:sp>
         <p:nvSpPr>
           <p:cNvPr id="2" name="Rectangle 1"/>
@@ -12446,6 +12704,7 @@
           <a:lstStyle/>
           <a:p>
             <a:pPr algn="ctr"/>
+            <a:endParaRPr/>
           </a:p>
         </p:txBody>
       </p:sp>
@@ -12648,7 +12907,7 @@
 </file>
 
 <file path=ppt/slides/slide37.xml><?xml version="1.0" encoding="utf-8"?>
-<p:sld xmlns:a="http://schemas.openxmlformats.org/drawingml/2006/main" xmlns:p="http://schemas.openxmlformats.org/presentationml/2006/main" xmlns:r="http://schemas.openxmlformats.org/officeDocument/2006/relationships">
+<p:sld xmlns:a="http://schemas.openxmlformats.org/drawingml/2006/main" xmlns:r="http://schemas.openxmlformats.org/officeDocument/2006/relationships" xmlns:p="http://schemas.openxmlformats.org/presentationml/2006/main">
   <p:cSld>
     <p:spTree>
       <p:nvGrpSpPr>
@@ -12656,7 +12915,14 @@
         <p:cNvGrpSpPr/>
         <p:nvPr/>
       </p:nvGrpSpPr>
-      <p:grpSpPr/>
+      <p:grpSpPr>
+        <a:xfrm>
+          <a:off x="0" y="0"/>
+          <a:ext cx="0" cy="0"/>
+          <a:chOff x="0" y="0"/>
+          <a:chExt cx="0" cy="0"/>
+        </a:xfrm>
+      </p:grpSpPr>
       <p:sp>
         <p:nvSpPr>
           <p:cNvPr id="2" name="Rectangle 1"/>
@@ -12698,6 +12964,7 @@
           <a:lstStyle/>
           <a:p>
             <a:pPr algn="ctr"/>
+            <a:endParaRPr/>
           </a:p>
         </p:txBody>
       </p:sp>
@@ -12884,7 +13151,7 @@
 </file>
 
 <file path=ppt/slides/slide4.xml><?xml version="1.0" encoding="utf-8"?>
-<p:sld xmlns:a="http://schemas.openxmlformats.org/drawingml/2006/main" xmlns:p="http://schemas.openxmlformats.org/presentationml/2006/main" xmlns:r="http://schemas.openxmlformats.org/officeDocument/2006/relationships">
+<p:sld xmlns:a="http://schemas.openxmlformats.org/drawingml/2006/main" xmlns:r="http://schemas.openxmlformats.org/officeDocument/2006/relationships" xmlns:p="http://schemas.openxmlformats.org/presentationml/2006/main">
   <p:cSld>
     <p:spTree>
       <p:nvGrpSpPr>
@@ -12892,7 +13159,14 @@
         <p:cNvGrpSpPr/>
         <p:nvPr/>
       </p:nvGrpSpPr>
-      <p:grpSpPr/>
+      <p:grpSpPr>
+        <a:xfrm>
+          <a:off x="0" y="0"/>
+          <a:ext cx="0" cy="0"/>
+          <a:chOff x="0" y="0"/>
+          <a:chExt cx="0" cy="0"/>
+        </a:xfrm>
+      </p:grpSpPr>
       <p:sp>
         <p:nvSpPr>
           <p:cNvPr id="2" name="Rectangle 1"/>
@@ -12934,6 +13208,7 @@
           <a:lstStyle/>
           <a:p>
             <a:pPr algn="ctr"/>
+            <a:endParaRPr/>
           </a:p>
         </p:txBody>
       </p:sp>
@@ -13056,6 +13331,7 @@
           <a:lstStyle/>
           <a:p>
             <a:pPr algn="ctr"/>
+            <a:endParaRPr/>
           </a:p>
         </p:txBody>
       </p:sp>
@@ -13155,7 +13431,7 @@
 </file>
 
 <file path=ppt/slides/slide5.xml><?xml version="1.0" encoding="utf-8"?>
-<p:sld xmlns:a="http://schemas.openxmlformats.org/drawingml/2006/main" xmlns:p="http://schemas.openxmlformats.org/presentationml/2006/main" xmlns:r="http://schemas.openxmlformats.org/officeDocument/2006/relationships">
+<p:sld xmlns:a="http://schemas.openxmlformats.org/drawingml/2006/main" xmlns:r="http://schemas.openxmlformats.org/officeDocument/2006/relationships" xmlns:p="http://schemas.openxmlformats.org/presentationml/2006/main">
   <p:cSld>
     <p:spTree>
       <p:nvGrpSpPr>
@@ -13163,7 +13439,14 @@
         <p:cNvGrpSpPr/>
         <p:nvPr/>
       </p:nvGrpSpPr>
-      <p:grpSpPr/>
+      <p:grpSpPr>
+        <a:xfrm>
+          <a:off x="0" y="0"/>
+          <a:ext cx="0" cy="0"/>
+          <a:chOff x="0" y="0"/>
+          <a:chExt cx="0" cy="0"/>
+        </a:xfrm>
+      </p:grpSpPr>
       <p:sp>
         <p:nvSpPr>
           <p:cNvPr id="2" name="Rectangle 1"/>
@@ -13205,6 +13488,7 @@
           <a:lstStyle/>
           <a:p>
             <a:pPr algn="ctr"/>
+            <a:endParaRPr/>
           </a:p>
         </p:txBody>
       </p:sp>
@@ -13398,7 +13682,7 @@
 </file>
 
 <file path=ppt/slides/slide6.xml><?xml version="1.0" encoding="utf-8"?>
-<p:sld xmlns:a="http://schemas.openxmlformats.org/drawingml/2006/main" xmlns:p="http://schemas.openxmlformats.org/presentationml/2006/main" xmlns:r="http://schemas.openxmlformats.org/officeDocument/2006/relationships">
+<p:sld xmlns:a="http://schemas.openxmlformats.org/drawingml/2006/main" xmlns:r="http://schemas.openxmlformats.org/officeDocument/2006/relationships" xmlns:p="http://schemas.openxmlformats.org/presentationml/2006/main">
   <p:cSld>
     <p:spTree>
       <p:nvGrpSpPr>
@@ -13406,7 +13690,14 @@
         <p:cNvGrpSpPr/>
         <p:nvPr/>
       </p:nvGrpSpPr>
-      <p:grpSpPr/>
+      <p:grpSpPr>
+        <a:xfrm>
+          <a:off x="0" y="0"/>
+          <a:ext cx="0" cy="0"/>
+          <a:chOff x="0" y="0"/>
+          <a:chExt cx="0" cy="0"/>
+        </a:xfrm>
+      </p:grpSpPr>
       <p:sp>
         <p:nvSpPr>
           <p:cNvPr id="2" name="Rectangle 1"/>
@@ -13448,6 +13739,7 @@
           <a:lstStyle/>
           <a:p>
             <a:pPr algn="ctr"/>
+            <a:endParaRPr/>
           </a:p>
         </p:txBody>
       </p:sp>
@@ -13641,7 +13933,7 @@
 </file>
 
 <file path=ppt/slides/slide7.xml><?xml version="1.0" encoding="utf-8"?>
-<p:sld xmlns:a="http://schemas.openxmlformats.org/drawingml/2006/main" xmlns:p="http://schemas.openxmlformats.org/presentationml/2006/main" xmlns:r="http://schemas.openxmlformats.org/officeDocument/2006/relationships">
+<p:sld xmlns:a="http://schemas.openxmlformats.org/drawingml/2006/main" xmlns:r="http://schemas.openxmlformats.org/officeDocument/2006/relationships" xmlns:p="http://schemas.openxmlformats.org/presentationml/2006/main">
   <p:cSld>
     <p:spTree>
       <p:nvGrpSpPr>
@@ -13649,7 +13941,14 @@
         <p:cNvGrpSpPr/>
         <p:nvPr/>
       </p:nvGrpSpPr>
-      <p:grpSpPr/>
+      <p:grpSpPr>
+        <a:xfrm>
+          <a:off x="0" y="0"/>
+          <a:ext cx="0" cy="0"/>
+          <a:chOff x="0" y="0"/>
+          <a:chExt cx="0" cy="0"/>
+        </a:xfrm>
+      </p:grpSpPr>
       <p:sp>
         <p:nvSpPr>
           <p:cNvPr id="2" name="Rectangle 1"/>
@@ -13691,6 +13990,7 @@
           <a:lstStyle/>
           <a:p>
             <a:pPr algn="ctr"/>
+            <a:endParaRPr/>
           </a:p>
         </p:txBody>
       </p:sp>
@@ -13884,7 +14184,7 @@
 </file>
 
 <file path=ppt/slides/slide8.xml><?xml version="1.0" encoding="utf-8"?>
-<p:sld xmlns:a="http://schemas.openxmlformats.org/drawingml/2006/main" xmlns:p="http://schemas.openxmlformats.org/presentationml/2006/main" xmlns:r="http://schemas.openxmlformats.org/officeDocument/2006/relationships">
+<p:sld xmlns:a="http://schemas.openxmlformats.org/drawingml/2006/main" xmlns:r="http://schemas.openxmlformats.org/officeDocument/2006/relationships" xmlns:p="http://schemas.openxmlformats.org/presentationml/2006/main">
   <p:cSld>
     <p:spTree>
       <p:nvGrpSpPr>
@@ -13892,7 +14192,14 @@
         <p:cNvGrpSpPr/>
         <p:nvPr/>
       </p:nvGrpSpPr>
-      <p:grpSpPr/>
+      <p:grpSpPr>
+        <a:xfrm>
+          <a:off x="0" y="0"/>
+          <a:ext cx="0" cy="0"/>
+          <a:chOff x="0" y="0"/>
+          <a:chExt cx="0" cy="0"/>
+        </a:xfrm>
+      </p:grpSpPr>
       <p:sp>
         <p:nvSpPr>
           <p:cNvPr id="2" name="Rectangle 1"/>
@@ -13934,6 +14241,7 @@
           <a:lstStyle/>
           <a:p>
             <a:pPr algn="ctr"/>
+            <a:endParaRPr/>
           </a:p>
         </p:txBody>
       </p:sp>
@@ -14127,7 +14435,7 @@
 </file>
 
 <file path=ppt/slides/slide9.xml><?xml version="1.0" encoding="utf-8"?>
-<p:sld xmlns:a="http://schemas.openxmlformats.org/drawingml/2006/main" xmlns:p="http://schemas.openxmlformats.org/presentationml/2006/main" xmlns:r="http://schemas.openxmlformats.org/officeDocument/2006/relationships">
+<p:sld xmlns:a="http://schemas.openxmlformats.org/drawingml/2006/main" xmlns:r="http://schemas.openxmlformats.org/officeDocument/2006/relationships" xmlns:p="http://schemas.openxmlformats.org/presentationml/2006/main">
   <p:cSld>
     <p:spTree>
       <p:nvGrpSpPr>
@@ -14135,7 +14443,14 @@
         <p:cNvGrpSpPr/>
         <p:nvPr/>
       </p:nvGrpSpPr>
-      <p:grpSpPr/>
+      <p:grpSpPr>
+        <a:xfrm>
+          <a:off x="0" y="0"/>
+          <a:ext cx="0" cy="0"/>
+          <a:chOff x="0" y="0"/>
+          <a:chExt cx="0" cy="0"/>
+        </a:xfrm>
+      </p:grpSpPr>
       <p:sp>
         <p:nvSpPr>
           <p:cNvPr id="2" name="Rectangle 1"/>
@@ -14177,6 +14492,7 @@
           <a:lstStyle/>
           <a:p>
             <a:pPr algn="ctr"/>
+            <a:endParaRPr/>
           </a:p>
         </p:txBody>
       </p:sp>
@@ -14690,7 +15006,7 @@
 </file>
 
 <file path=ppt/theme/theme2.xml><?xml version="1.0" encoding="utf-8"?>
-<a:theme xmlns:a="http://schemas.openxmlformats.org/drawingml/2006/main" name="Office Theme">
+<a:theme xmlns:a="http://schemas.openxmlformats.org/drawingml/2006/main" name="Office 테마">
   <a:themeElements>
     <a:clrScheme name="Office">
       <a:dk1>
@@ -14700,44 +15016,44 @@
         <a:sysClr val="window" lastClr="FFFFFF"/>
       </a:lt1>
       <a:dk2>
-        <a:srgbClr val="1F497D"/>
+        <a:srgbClr val="0E2841"/>
       </a:dk2>
       <a:lt2>
-        <a:srgbClr val="EEECE1"/>
+        <a:srgbClr val="E8E8E8"/>
       </a:lt2>
       <a:accent1>
-        <a:srgbClr val="4F81BD"/>
+        <a:srgbClr val="156082"/>
       </a:accent1>
       <a:accent2>
-        <a:srgbClr val="C0504D"/>
+        <a:srgbClr val="E97132"/>
       </a:accent2>
       <a:accent3>
-        <a:srgbClr val="9BBB59"/>
+        <a:srgbClr val="196B24"/>
       </a:accent3>
       <a:accent4>
-        <a:srgbClr val="8064A2"/>
+        <a:srgbClr val="0F9ED5"/>
       </a:accent4>
       <a:accent5>
-        <a:srgbClr val="4BACC6"/>
+        <a:srgbClr val="A02B93"/>
       </a:accent5>
       <a:accent6>
-        <a:srgbClr val="F79646"/>
+        <a:srgbClr val="4EA72E"/>
       </a:accent6>
       <a:hlink>
-        <a:srgbClr val="0000FF"/>
+        <a:srgbClr val="467886"/>
       </a:hlink>
       <a:folHlink>
-        <a:srgbClr val="800080"/>
+        <a:srgbClr val="96607D"/>
       </a:folHlink>
     </a:clrScheme>
     <a:fontScheme name="Office">
       <a:majorFont>
-        <a:latin typeface="Calibri"/>
+        <a:latin typeface="맑은 고딕" panose="02110004020202020204"/>
         <a:ea typeface=""/>
         <a:cs typeface=""/>
-        <a:font script="Jpan" typeface="ＭＳ Ｐゴシック"/>
+        <a:font script="Jpan" typeface="游ゴシック Light"/>
         <a:font script="Hang" typeface="맑은 고딕"/>
-        <a:font script="Hans" typeface="宋体"/>
+        <a:font script="Hans" typeface="等线 Light"/>
         <a:font script="Hant" typeface="新細明體"/>
         <a:font script="Arab" typeface="Times New Roman"/>
         <a:font script="Hebr" typeface="Times New Roman"/>
@@ -14765,14 +15081,31 @@
         <a:font script="Viet" typeface="Times New Roman"/>
         <a:font script="Uigh" typeface="Microsoft Uighur"/>
         <a:font script="Geor" typeface="Sylfaen"/>
+        <a:font script="Armn" typeface="Arial"/>
+        <a:font script="Bugi" typeface="Leelawadee UI"/>
+        <a:font script="Bopo" typeface="Microsoft JhengHei"/>
+        <a:font script="Java" typeface="Javanese Text"/>
+        <a:font script="Lisu" typeface="Segoe UI"/>
+        <a:font script="Mymr" typeface="Myanmar Text"/>
+        <a:font script="Nkoo" typeface="Ebrima"/>
+        <a:font script="Olck" typeface="Nirmala UI"/>
+        <a:font script="Osma" typeface="Ebrima"/>
+        <a:font script="Phag" typeface="Phagspa"/>
+        <a:font script="Syrn" typeface="Estrangelo Edessa"/>
+        <a:font script="Syrj" typeface="Estrangelo Edessa"/>
+        <a:font script="Syre" typeface="Estrangelo Edessa"/>
+        <a:font script="Sora" typeface="Nirmala UI"/>
+        <a:font script="Tale" typeface="Microsoft Tai Le"/>
+        <a:font script="Talu" typeface="Microsoft New Tai Lue"/>
+        <a:font script="Tfng" typeface="Ebrima"/>
       </a:majorFont>
       <a:minorFont>
-        <a:latin typeface="Calibri"/>
+        <a:latin typeface="맑은 고딕" panose="02110004020202020204"/>
         <a:ea typeface=""/>
         <a:cs typeface=""/>
-        <a:font script="Jpan" typeface="ＭＳ Ｐゴシック"/>
+        <a:font script="Jpan" typeface="游ゴシック"/>
         <a:font script="Hang" typeface="맑은 고딕"/>
-        <a:font script="Hans" typeface="宋体"/>
+        <a:font script="Hans" typeface="等线"/>
         <a:font script="Hant" typeface="新細明體"/>
         <a:font script="Arab" typeface="Arial"/>
         <a:font script="Hebr" typeface="Arial"/>
@@ -14800,6 +15133,23 @@
         <a:font script="Viet" typeface="Arial"/>
         <a:font script="Uigh" typeface="Microsoft Uighur"/>
         <a:font script="Geor" typeface="Sylfaen"/>
+        <a:font script="Armn" typeface="Arial"/>
+        <a:font script="Bugi" typeface="Leelawadee UI"/>
+        <a:font script="Bopo" typeface="Microsoft JhengHei"/>
+        <a:font script="Java" typeface="Javanese Text"/>
+        <a:font script="Lisu" typeface="Segoe UI"/>
+        <a:font script="Mymr" typeface="Myanmar Text"/>
+        <a:font script="Nkoo" typeface="Ebrima"/>
+        <a:font script="Olck" typeface="Nirmala UI"/>
+        <a:font script="Osma" typeface="Ebrima"/>
+        <a:font script="Phag" typeface="Phagspa"/>
+        <a:font script="Syrn" typeface="Estrangelo Edessa"/>
+        <a:font script="Syrj" typeface="Estrangelo Edessa"/>
+        <a:font script="Syre" typeface="Estrangelo Edessa"/>
+        <a:font script="Sora" typeface="Nirmala UI"/>
+        <a:font script="Tale" typeface="Microsoft Tai Le"/>
+        <a:font script="Talu" typeface="Microsoft New Tai Lue"/>
+        <a:font script="Tfng" typeface="Ebrima"/>
       </a:minorFont>
     </a:fontScheme>
     <a:fmtScheme name="Office">
@@ -14811,180 +15161,136 @@
           <a:gsLst>
             <a:gs pos="0">
               <a:schemeClr val="phClr">
-                <a:tint val="50000"/>
-                <a:satMod val="300000"/>
+                <a:lumMod val="110000"/>
+                <a:satMod val="105000"/>
+                <a:tint val="67000"/>
               </a:schemeClr>
             </a:gs>
-            <a:gs pos="35000">
+            <a:gs pos="50000">
               <a:schemeClr val="phClr">
-                <a:tint val="37000"/>
-                <a:satMod val="300000"/>
+                <a:lumMod val="105000"/>
+                <a:satMod val="103000"/>
+                <a:tint val="73000"/>
               </a:schemeClr>
             </a:gs>
             <a:gs pos="100000">
               <a:schemeClr val="phClr">
-                <a:tint val="15000"/>
-                <a:satMod val="350000"/>
+                <a:lumMod val="105000"/>
+                <a:satMod val="109000"/>
+                <a:tint val="81000"/>
               </a:schemeClr>
             </a:gs>
           </a:gsLst>
-          <a:lin ang="16200000" scaled="1"/>
+          <a:lin ang="5400000" scaled="0"/>
         </a:gradFill>
         <a:gradFill rotWithShape="1">
           <a:gsLst>
             <a:gs pos="0">
               <a:schemeClr val="phClr">
-                <a:tint val="100000"/>
+                <a:satMod val="103000"/>
+                <a:lumMod val="102000"/>
+                <a:tint val="94000"/>
+              </a:schemeClr>
+            </a:gs>
+            <a:gs pos="50000">
+              <a:schemeClr val="phClr">
+                <a:satMod val="110000"/>
+                <a:lumMod val="100000"/>
                 <a:shade val="100000"/>
-                <a:satMod val="130000"/>
               </a:schemeClr>
             </a:gs>
             <a:gs pos="100000">
               <a:schemeClr val="phClr">
-                <a:tint val="50000"/>
-                <a:shade val="100000"/>
-                <a:satMod val="350000"/>
+                <a:lumMod val="99000"/>
+                <a:satMod val="120000"/>
+                <a:shade val="78000"/>
               </a:schemeClr>
             </a:gs>
           </a:gsLst>
-          <a:lin ang="16200000" scaled="0"/>
+          <a:lin ang="5400000" scaled="0"/>
         </a:gradFill>
       </a:fillStyleLst>
       <a:lnStyleLst>
-        <a:ln w="9525" cap="flat" cmpd="sng" algn="ctr">
+        <a:ln w="12700" cap="flat" cmpd="sng" algn="ctr">
           <a:solidFill>
-            <a:schemeClr val="phClr">
-              <a:shade val="95000"/>
-              <a:satMod val="105000"/>
-            </a:schemeClr>
+            <a:schemeClr val="phClr"/>
           </a:solidFill>
           <a:prstDash val="solid"/>
+          <a:miter lim="800000"/>
+        </a:ln>
+        <a:ln w="19050" cap="flat" cmpd="sng" algn="ctr">
+          <a:solidFill>
+            <a:schemeClr val="phClr"/>
+          </a:solidFill>
+          <a:prstDash val="solid"/>
+          <a:miter lim="800000"/>
         </a:ln>
         <a:ln w="25400" cap="flat" cmpd="sng" algn="ctr">
           <a:solidFill>
             <a:schemeClr val="phClr"/>
           </a:solidFill>
           <a:prstDash val="solid"/>
-        </a:ln>
-        <a:ln w="38100" cap="flat" cmpd="sng" algn="ctr">
-          <a:solidFill>
-            <a:schemeClr val="phClr"/>
-          </a:solidFill>
-          <a:prstDash val="solid"/>
+          <a:miter lim="800000"/>
         </a:ln>
       </a:lnStyleLst>
       <a:effectStyleLst>
         <a:effectStyle>
+          <a:effectLst/>
+        </a:effectStyle>
+        <a:effectStyle>
+          <a:effectLst/>
+        </a:effectStyle>
+        <a:effectStyle>
           <a:effectLst>
-            <a:outerShdw blurRad="40000" dist="20000" dir="5400000" rotWithShape="0">
+            <a:outerShdw blurRad="57150" dist="19050" dir="5400000" algn="ctr" rotWithShape="0">
               <a:srgbClr val="000000">
-                <a:alpha val="38000"/>
+                <a:alpha val="63000"/>
               </a:srgbClr>
             </a:outerShdw>
           </a:effectLst>
-        </a:effectStyle>
-        <a:effectStyle>
-          <a:effectLst>
-            <a:outerShdw blurRad="40000" dist="23000" dir="5400000" rotWithShape="0">
-              <a:srgbClr val="000000">
-                <a:alpha val="35000"/>
-              </a:srgbClr>
-            </a:outerShdw>
-          </a:effectLst>
-        </a:effectStyle>
-        <a:effectStyle>
-          <a:effectLst>
-            <a:outerShdw blurRad="40000" dist="23000" dir="5400000" rotWithShape="0">
-              <a:srgbClr val="000000">
-                <a:alpha val="35000"/>
-              </a:srgbClr>
-            </a:outerShdw>
-          </a:effectLst>
-          <a:scene3d>
-            <a:camera prst="orthographicFront">
-              <a:rot lat="0" lon="0" rev="0"/>
-            </a:camera>
-            <a:lightRig rig="threePt" dir="t">
-              <a:rot lat="0" lon="0" rev="1200000"/>
-            </a:lightRig>
-          </a:scene3d>
-          <a:sp3d>
-            <a:bevelT w="63500" h="25400"/>
-          </a:sp3d>
         </a:effectStyle>
       </a:effectStyleLst>
       <a:bgFillStyleLst>
         <a:solidFill>
           <a:schemeClr val="phClr"/>
         </a:solidFill>
+        <a:solidFill>
+          <a:schemeClr val="phClr">
+            <a:tint val="95000"/>
+            <a:satMod val="170000"/>
+          </a:schemeClr>
+        </a:solidFill>
         <a:gradFill rotWithShape="1">
           <a:gsLst>
             <a:gs pos="0">
               <a:schemeClr val="phClr">
-                <a:tint val="40000"/>
-                <a:satMod val="350000"/>
+                <a:tint val="93000"/>
+                <a:satMod val="150000"/>
+                <a:shade val="98000"/>
+                <a:lumMod val="102000"/>
               </a:schemeClr>
             </a:gs>
-            <a:gs pos="40000">
+            <a:gs pos="50000">
               <a:schemeClr val="phClr">
-                <a:tint val="45000"/>
-                <a:shade val="99000"/>
-                <a:satMod val="350000"/>
+                <a:tint val="98000"/>
+                <a:satMod val="130000"/>
+                <a:shade val="90000"/>
+                <a:lumMod val="103000"/>
               </a:schemeClr>
             </a:gs>
             <a:gs pos="100000">
               <a:schemeClr val="phClr">
-                <a:shade val="20000"/>
-                <a:satMod val="255000"/>
+                <a:shade val="63000"/>
+                <a:satMod val="120000"/>
               </a:schemeClr>
             </a:gs>
           </a:gsLst>
-          <a:path path="circle">
-            <a:fillToRect l="50000" t="-80000" r="50000" b="180000"/>
-          </a:path>
-        </a:gradFill>
-        <a:gradFill rotWithShape="1">
-          <a:gsLst>
-            <a:gs pos="0">
-              <a:schemeClr val="phClr">
-                <a:tint val="80000"/>
-                <a:satMod val="300000"/>
-              </a:schemeClr>
-            </a:gs>
-            <a:gs pos="100000">
-              <a:schemeClr val="phClr">
-                <a:shade val="30000"/>
-                <a:satMod val="200000"/>
-              </a:schemeClr>
-            </a:gs>
-          </a:gsLst>
-          <a:path path="circle">
-            <a:fillToRect l="50000" t="50000" r="50000" b="50000"/>
-          </a:path>
+          <a:lin ang="5400000" scaled="0"/>
         </a:gradFill>
       </a:bgFillStyleLst>
     </a:fmtScheme>
   </a:themeElements>
   <a:objectDefaults>
-    <a:spDef>
-      <a:spPr/>
-      <a:bodyPr/>
-      <a:lstStyle/>
-      <a:style>
-        <a:lnRef idx="1">
-          <a:schemeClr val="accent1"/>
-        </a:lnRef>
-        <a:fillRef idx="3">
-          <a:schemeClr val="accent1"/>
-        </a:fillRef>
-        <a:effectRef idx="2">
-          <a:schemeClr val="accent1"/>
-        </a:effectRef>
-        <a:fontRef idx="minor">
-          <a:schemeClr val="lt1"/>
-        </a:fontRef>
-      </a:style>
-    </a:spDef>
     <a:lnDef>
       <a:spPr/>
       <a:bodyPr/>
@@ -15006,5 +15312,10 @@
     </a:lnDef>
   </a:objectDefaults>
   <a:extraClrSchemeLst/>
+  <a:extLst>
+    <a:ext uri="{05A4C25C-085E-4340-85A3-A5531E510DB2}">
+      <thm15:themeFamily xmlns:thm15="http://schemas.microsoft.com/office/thememl/2012/main" name="Office Theme" id="{2E142A2C-CD16-42D6-873A-C26D2A0506FA}" vid="{1BDDFF52-6CD6-40A5-AB3C-68EB2F1E4D0A}"/>
+    </a:ext>
+  </a:extLst>
 </a:theme>
 </file>
</xml_diff>